<commit_message>
Deck: show orchestrator duties as one responsibilities line, not five boxes
Co-Authored-By: Claude Sonnet 5.5 <noreply@anthropic.com>
Claude-Session: https://claude.ai/code/session_01Aj5vE1JNcAxiTqppU4PS2Y
</commit_message>
<xml_diff>
--- a/docs/Campaign_Provisioner_Management_Deck.pptx
+++ b/docs/Campaign_Provisioner_Management_Deck.pptx
@@ -2343,46 +2343,7 @@
       </p:sp>
       <p:sp>
         <p:nvSpPr>
-          <p:cNvPr id="19" name="Text 17"/>
-          <p:cNvSpPr txBox="1"/>
-          <p:nvPr/>
-        </p:nvSpPr>
-        <p:spPr>
-          <a:xfrm>
-            <a:off x="2880360" y="1261872"/>
-            <a:ext cx="822960" cy="201168"/>
-          </a:xfrm>
-          <a:prstGeom prst="rect">
-            <a:avLst/>
-          </a:prstGeom>
-          <a:noFill/>
-          <a:ln/>
-        </p:spPr>
-        <p:txBody>
-          <a:bodyPr wrap="square" lIns="25400" tIns="25400" rIns="25400" bIns="25400" rtlCol="0" anchor="ctr"/>
-          <a:lstStyle/>
-          <a:p>
-            <a:pPr algn="ctr" indent="0" marL="0">
-              <a:buNone/>
-            </a:pPr>
-            <a:r>
-              <a:rPr lang="en-US" sz="800" b="1" dirty="0">
-                <a:solidFill>
-                  <a:srgbClr val="FFFFFF"/>
-                </a:solidFill>
-                <a:latin typeface="Calibri" pitchFamily="34" charset="0"/>
-                <a:ea typeface="Calibri" pitchFamily="34" charset="-122"/>
-                <a:cs typeface="Calibri" pitchFamily="34" charset="-120"/>
-              </a:rPr>
-              <a:t>Root Agent</a:t>
-            </a:r>
-            <a:endParaRPr lang="en-US" sz="800" dirty="0"/>
-          </a:p>
-        </p:txBody>
-      </p:sp>
-      <p:sp>
-        <p:nvSpPr>
-          <p:cNvPr id="20" name="Shape 18"/>
+          <p:cNvPr id="19" name="Shape 17"/>
           <p:cNvSpPr/>
           <p:nvPr/>
         </p:nvSpPr>
@@ -2409,7 +2370,7 @@
       </p:sp>
       <p:sp>
         <p:nvSpPr>
-          <p:cNvPr id="21" name="Text 19"/>
+          <p:cNvPr id="20" name="Text 18"/>
           <p:cNvSpPr txBox="1"/>
           <p:nvPr/>
         </p:nvSpPr>
@@ -2448,14 +2409,14 @@
       </p:sp>
       <p:sp>
         <p:nvSpPr>
-          <p:cNvPr id="22" name="Text 20"/>
-          <p:cNvSpPr txBox="1"/>
-          <p:nvPr/>
-        </p:nvSpPr>
-        <p:spPr>
-          <a:xfrm>
-            <a:off x="2926080" y="1481328"/>
-            <a:ext cx="6309360" cy="274320"/>
+          <p:cNvPr id="21" name="Text 19"/>
+          <p:cNvSpPr txBox="1"/>
+          <p:nvPr/>
+        </p:nvSpPr>
+        <p:spPr>
+          <a:xfrm>
+            <a:off x="2926080" y="1499616"/>
+            <a:ext cx="6309360" cy="310896"/>
           </a:xfrm>
           <a:prstGeom prst="rect">
             <a:avLst/>
@@ -2487,18 +2448,18 @@
       </p:sp>
       <p:sp>
         <p:nvSpPr>
-          <p:cNvPr id="23" name="Shape 21"/>
+          <p:cNvPr id="22" name="Shape 20"/>
           <p:cNvSpPr/>
           <p:nvPr/>
         </p:nvSpPr>
         <p:spPr>
           <a:xfrm>
-            <a:off x="2971800" y="1828800"/>
-            <a:ext cx="1188720" cy="411480"/>
+            <a:off x="2971800" y="1847088"/>
+            <a:ext cx="6217920" cy="457200"/>
           </a:xfrm>
           <a:prstGeom prst="roundRect">
             <a:avLst>
-              <a:gd name="adj" fmla="val 13333"/>
+              <a:gd name="adj" fmla="val 12000"/>
             </a:avLst>
           </a:prstGeom>
           <a:solidFill>
@@ -2514,14 +2475,14 @@
       </p:sp>
       <p:sp>
         <p:nvSpPr>
-          <p:cNvPr id="24" name="Text 22"/>
+          <p:cNvPr id="23" name="Text 21"/>
           <p:cNvSpPr txBox="1"/>
           <p:nvPr/>
         </p:nvSpPr>
         <p:spPr>
           <a:xfrm>
             <a:off x="3017520" y="1865376"/>
-            <a:ext cx="1097280" cy="338328"/>
+            <a:ext cx="6126480" cy="420624"/>
           </a:xfrm>
           <a:prstGeom prst="rect">
             <a:avLst/>
@@ -2537,7 +2498,21 @@
               <a:buNone/>
             </a:pPr>
             <a:r>
-              <a:rPr lang="en-US" sz="800" b="1" dirty="0">
+              <a:rPr lang="en-US" sz="850" b="1" dirty="0">
+                <a:solidFill>
+                  <a:srgbClr val="1F3A8A"/>
+                </a:solidFill>
+                <a:latin typeface="Calibri" pitchFamily="34" charset="0"/>
+                <a:ea typeface="Calibri" pitchFamily="34" charset="-122"/>
+                <a:cs typeface="Calibri" pitchFamily="34" charset="-120"/>
+              </a:rPr>
+              <a:t>Responsibilities of this single agent:  </a:t>
+            </a:r>
+            <a:pPr algn="ctr" indent="0" marL="0">
+              <a:buNone/>
+            </a:pPr>
+            <a:r>
+              <a:rPr lang="en-US" sz="850" dirty="0">
                 <a:solidFill>
                   <a:srgbClr val="1E293B"/>
                 </a:solidFill>
@@ -2545,11 +2520,36 @@
                 <a:ea typeface="Calibri" pitchFamily="34" charset="-122"/>
                 <a:cs typeface="Calibri" pitchFamily="34" charset="-120"/>
               </a:rPr>
-              <a:t>Greeting &amp; Intent</a:t>
-            </a:r>
-            <a:endParaRPr lang="en-US" sz="800" dirty="0"/>
-          </a:p>
-        </p:txBody>
+              <a:t>Greeting &amp; Intent  •  Multi-Agent Coordination  •  State Coordination  •  Human Approval Gate  •  Result Aggregation</a:t>
+            </a:r>
+            <a:endParaRPr lang="en-US" sz="850" dirty="0"/>
+          </a:p>
+        </p:txBody>
+      </p:sp>
+      <p:sp>
+        <p:nvSpPr>
+          <p:cNvPr id="24" name="Shape 22"/>
+          <p:cNvSpPr/>
+          <p:nvPr/>
+        </p:nvSpPr>
+        <p:spPr>
+          <a:xfrm>
+            <a:off x="2834640" y="2560320"/>
+            <a:ext cx="6492240" cy="1874520"/>
+          </a:xfrm>
+          <a:prstGeom prst="rect">
+            <a:avLst/>
+          </a:prstGeom>
+          <a:solidFill>
+            <a:srgbClr val="E8F0FF"/>
+          </a:solidFill>
+          <a:ln w="12700">
+            <a:solidFill>
+              <a:srgbClr val="93A8D8"/>
+            </a:solidFill>
+            <a:prstDash val="dash"/>
+          </a:ln>
+        </p:spPr>
       </p:sp>
       <p:sp>
         <p:nvSpPr>
@@ -2559,16 +2559,80 @@
         </p:nvSpPr>
         <p:spPr>
           <a:xfrm>
-            <a:off x="4224528" y="1828800"/>
-            <a:ext cx="1188720" cy="411480"/>
+            <a:off x="2880360" y="2496312"/>
+            <a:ext cx="914400" cy="201168"/>
           </a:xfrm>
           <a:prstGeom prst="roundRect">
             <a:avLst>
-              <a:gd name="adj" fmla="val 13333"/>
+              <a:gd name="adj" fmla="val 22727"/>
             </a:avLst>
           </a:prstGeom>
           <a:solidFill>
-            <a:srgbClr val="FFFFFF"/>
+            <a:srgbClr val="2563EB"/>
+          </a:solidFill>
+          <a:ln w="12700">
+            <a:solidFill>
+              <a:srgbClr val="2563EB"/>
+            </a:solidFill>
+            <a:prstDash val="solid"/>
+          </a:ln>
+        </p:spPr>
+      </p:sp>
+      <p:sp>
+        <p:nvSpPr>
+          <p:cNvPr id="26" name="Text 24"/>
+          <p:cNvSpPr txBox="1"/>
+          <p:nvPr/>
+        </p:nvSpPr>
+        <p:spPr>
+          <a:xfrm>
+            <a:off x="2880360" y="2496312"/>
+            <a:ext cx="914400" cy="201168"/>
+          </a:xfrm>
+          <a:prstGeom prst="rect">
+            <a:avLst/>
+          </a:prstGeom>
+          <a:noFill/>
+          <a:ln/>
+        </p:spPr>
+        <p:txBody>
+          <a:bodyPr wrap="square" lIns="25400" tIns="25400" rIns="25400" bIns="25400" rtlCol="0" anchor="ctr"/>
+          <a:lstStyle/>
+          <a:p>
+            <a:pPr algn="ctr" indent="0" marL="0">
+              <a:buNone/>
+            </a:pPr>
+            <a:r>
+              <a:rPr lang="en-US" sz="800" b="1" dirty="0">
+                <a:solidFill>
+                  <a:srgbClr val="FFFFFF"/>
+                </a:solidFill>
+                <a:latin typeface="Calibri" pitchFamily="34" charset="0"/>
+                <a:ea typeface="Calibri" pitchFamily="34" charset="-122"/>
+                <a:cs typeface="Calibri" pitchFamily="34" charset="-120"/>
+              </a:rPr>
+              <a:t>3 Sub Agents</a:t>
+            </a:r>
+            <a:endParaRPr lang="en-US" sz="800" dirty="0"/>
+          </a:p>
+        </p:txBody>
+      </p:sp>
+      <p:sp>
+        <p:nvSpPr>
+          <p:cNvPr id="27" name="Shape 25"/>
+          <p:cNvSpPr/>
+          <p:nvPr/>
+        </p:nvSpPr>
+        <p:spPr>
+          <a:xfrm>
+            <a:off x="2926080" y="2788920"/>
+            <a:ext cx="2057400" cy="1554480"/>
+          </a:xfrm>
+          <a:prstGeom prst="rect">
+            <a:avLst/>
+          </a:prstGeom>
+          <a:solidFill>
+            <a:srgbClr val="F0F7FF"/>
           </a:solidFill>
           <a:ln w="12700">
             <a:solidFill>
@@ -2580,14 +2644,14 @@
       </p:sp>
       <p:sp>
         <p:nvSpPr>
-          <p:cNvPr id="26" name="Text 24"/>
-          <p:cNvSpPr txBox="1"/>
-          <p:nvPr/>
-        </p:nvSpPr>
-        <p:spPr>
-          <a:xfrm>
-            <a:off x="4270248" y="1865376"/>
-            <a:ext cx="1097280" cy="338328"/>
+          <p:cNvPr id="28" name="Text 26"/>
+          <p:cNvSpPr txBox="1"/>
+          <p:nvPr/>
+        </p:nvSpPr>
+        <p:spPr>
+          <a:xfrm>
+            <a:off x="2971800" y="2816352"/>
+            <a:ext cx="1965960" cy="256032"/>
           </a:xfrm>
           <a:prstGeom prst="rect">
             <a:avLst/>
@@ -2603,7 +2667,111 @@
               <a:buNone/>
             </a:pPr>
             <a:r>
-              <a:rPr lang="en-US" sz="800" b="1" dirty="0">
+              <a:rPr lang="en-US" sz="1000" b="1" dirty="0">
+                <a:solidFill>
+                  <a:srgbClr val="6D28D9"/>
+                </a:solidFill>
+                <a:latin typeface="Calibri" pitchFamily="34" charset="0"/>
+                <a:ea typeface="Calibri" pitchFamily="34" charset="-122"/>
+                <a:cs typeface="Calibri" pitchFamily="34" charset="-120"/>
+              </a:rPr>
+              <a:t>1. Inventory Agent</a:t>
+            </a:r>
+            <a:endParaRPr lang="en-US" sz="1000" dirty="0"/>
+          </a:p>
+        </p:txBody>
+      </p:sp>
+      <p:sp>
+        <p:nvSpPr>
+          <p:cNvPr id="29" name="Text 27"/>
+          <p:cNvSpPr txBox="1"/>
+          <p:nvPr/>
+        </p:nvSpPr>
+        <p:spPr>
+          <a:xfrm>
+            <a:off x="2971800" y="3054096"/>
+            <a:ext cx="1965960" cy="201168"/>
+          </a:xfrm>
+          <a:prstGeom prst="rect">
+            <a:avLst/>
+          </a:prstGeom>
+          <a:noFill/>
+          <a:ln/>
+        </p:spPr>
+        <p:txBody>
+          <a:bodyPr wrap="square" lIns="25400" tIns="25400" rIns="25400" bIns="25400" rtlCol="0" anchor="ctr"/>
+          <a:lstStyle/>
+          <a:p>
+            <a:pPr algn="ctr" indent="0" marL="0">
+              <a:buNone/>
+            </a:pPr>
+            <a:r>
+              <a:rPr lang="en-US" sz="800" dirty="0">
+                <a:solidFill>
+                  <a:srgbClr val="6D28D9"/>
+                </a:solidFill>
+                <a:latin typeface="Calibri" pitchFamily="34" charset="0"/>
+                <a:ea typeface="Calibri" pitchFamily="34" charset="-122"/>
+                <a:cs typeface="Calibri" pitchFamily="34" charset="-120"/>
+              </a:rPr>
+              <a:t>(Check &amp; Reserve Stock)</a:t>
+            </a:r>
+            <a:endParaRPr lang="en-US" sz="800" dirty="0"/>
+          </a:p>
+        </p:txBody>
+      </p:sp>
+      <p:sp>
+        <p:nvSpPr>
+          <p:cNvPr id="30" name="Shape 28"/>
+          <p:cNvSpPr/>
+          <p:nvPr/>
+        </p:nvSpPr>
+        <p:spPr>
+          <a:xfrm>
+            <a:off x="3017520" y="3310128"/>
+            <a:ext cx="1874520" cy="960120"/>
+          </a:xfrm>
+          <a:prstGeom prst="rect">
+            <a:avLst/>
+          </a:prstGeom>
+          <a:solidFill>
+            <a:srgbClr val="FFFFFF"/>
+          </a:solidFill>
+          <a:ln w="12700">
+            <a:solidFill>
+              <a:srgbClr val="D6E0F5"/>
+            </a:solidFill>
+            <a:prstDash val="solid"/>
+          </a:ln>
+        </p:spPr>
+      </p:sp>
+      <p:sp>
+        <p:nvSpPr>
+          <p:cNvPr id="31" name="Text 29"/>
+          <p:cNvSpPr txBox="1"/>
+          <p:nvPr/>
+        </p:nvSpPr>
+        <p:spPr>
+          <a:xfrm>
+            <a:off x="3063240" y="3346704"/>
+            <a:ext cx="1783080" cy="886968"/>
+          </a:xfrm>
+          <a:prstGeom prst="rect">
+            <a:avLst/>
+          </a:prstGeom>
+          <a:noFill/>
+          <a:ln/>
+        </p:spPr>
+        <p:txBody>
+          <a:bodyPr wrap="square" lIns="25400" tIns="25400" rIns="25400" bIns="25400" rtlCol="0" anchor="ctr"/>
+          <a:lstStyle/>
+          <a:p>
+            <a:pPr marL="342900" indent="-342900">
+              <a:buSzPct val="100000"/>
+              <a:buChar char="•"/>
+            </a:pPr>
+            <a:r>
+              <a:rPr lang="en-US" sz="850" dirty="0">
                 <a:solidFill>
                   <a:srgbClr val="1E293B"/>
                 </a:solidFill>
@@ -2611,30 +2779,64 @@
                 <a:ea typeface="Calibri" pitchFamily="34" charset="-122"/>
                 <a:cs typeface="Calibri" pitchFamily="34" charset="-120"/>
               </a:rPr>
-              <a:t>Multi-Agent Coordination</a:t>
-            </a:r>
-            <a:endParaRPr lang="en-US" sz="800" dirty="0"/>
-          </a:p>
-        </p:txBody>
-      </p:sp>
-      <p:sp>
-        <p:nvSpPr>
-          <p:cNvPr id="27" name="Shape 25"/>
+              <a:t>Check live stock by SKU</a:t>
+            </a:r>
+            <a:endParaRPr lang="en-US" sz="850" dirty="0"/>
+          </a:p>
+          <a:p>
+            <a:pPr marL="342900" indent="-342900">
+              <a:buSzPct val="100000"/>
+              <a:buChar char="•"/>
+            </a:pPr>
+            <a:r>
+              <a:rPr lang="en-US" sz="850" dirty="0">
+                <a:solidFill>
+                  <a:srgbClr val="1E293B"/>
+                </a:solidFill>
+                <a:latin typeface="Calibri" pitchFamily="34" charset="0"/>
+                <a:ea typeface="Calibri" pitchFamily="34" charset="-122"/>
+                <a:cs typeface="Calibri" pitchFamily="34" charset="-120"/>
+              </a:rPr>
+              <a:t>Reserve available units</a:t>
+            </a:r>
+            <a:endParaRPr lang="en-US" sz="850" dirty="0"/>
+          </a:p>
+          <a:p>
+            <a:pPr marL="342900" indent="-342900">
+              <a:buSzPct val="100000"/>
+              <a:buChar char="•"/>
+            </a:pPr>
+            <a:r>
+              <a:rPr lang="en-US" sz="850" dirty="0">
+                <a:solidFill>
+                  <a:srgbClr val="1E293B"/>
+                </a:solidFill>
+                <a:latin typeface="Calibri" pitchFamily="34" charset="0"/>
+                <a:ea typeface="Calibri" pitchFamily="34" charset="-122"/>
+                <a:cs typeface="Calibri" pitchFamily="34" charset="-120"/>
+              </a:rPr>
+              <a:t>Report shortfall to procure</a:t>
+            </a:r>
+            <a:endParaRPr lang="en-US" sz="850" dirty="0"/>
+          </a:p>
+        </p:txBody>
+      </p:sp>
+      <p:sp>
+        <p:nvSpPr>
+          <p:cNvPr id="32" name="Shape 30"/>
           <p:cNvSpPr/>
           <p:nvPr/>
         </p:nvSpPr>
         <p:spPr>
           <a:xfrm>
-            <a:off x="5477256" y="1828800"/>
-            <a:ext cx="1188720" cy="411480"/>
-          </a:xfrm>
-          <a:prstGeom prst="roundRect">
-            <a:avLst>
-              <a:gd name="adj" fmla="val 13333"/>
-            </a:avLst>
-          </a:prstGeom>
-          <a:solidFill>
-            <a:srgbClr val="FFFFFF"/>
+            <a:off x="5056632" y="2788920"/>
+            <a:ext cx="2057400" cy="1554480"/>
+          </a:xfrm>
+          <a:prstGeom prst="rect">
+            <a:avLst/>
+          </a:prstGeom>
+          <a:solidFill>
+            <a:srgbClr val="F3EEFF"/>
           </a:solidFill>
           <a:ln w="12700">
             <a:solidFill>
@@ -2646,14 +2848,14 @@
       </p:sp>
       <p:sp>
         <p:nvSpPr>
-          <p:cNvPr id="28" name="Text 26"/>
-          <p:cNvSpPr txBox="1"/>
-          <p:nvPr/>
-        </p:nvSpPr>
-        <p:spPr>
-          <a:xfrm>
-            <a:off x="5522976" y="1865376"/>
-            <a:ext cx="1097280" cy="338328"/>
+          <p:cNvPr id="33" name="Text 31"/>
+          <p:cNvSpPr txBox="1"/>
+          <p:nvPr/>
+        </p:nvSpPr>
+        <p:spPr>
+          <a:xfrm>
+            <a:off x="5102352" y="2816352"/>
+            <a:ext cx="1965960" cy="256032"/>
           </a:xfrm>
           <a:prstGeom prst="rect">
             <a:avLst/>
@@ -2669,7 +2871,111 @@
               <a:buNone/>
             </a:pPr>
             <a:r>
-              <a:rPr lang="en-US" sz="800" b="1" dirty="0">
+              <a:rPr lang="en-US" sz="1000" b="1" dirty="0">
+                <a:solidFill>
+                  <a:srgbClr val="6D28D9"/>
+                </a:solidFill>
+                <a:latin typeface="Calibri" pitchFamily="34" charset="0"/>
+                <a:ea typeface="Calibri" pitchFamily="34" charset="-122"/>
+                <a:cs typeface="Calibri" pitchFamily="34" charset="-120"/>
+              </a:rPr>
+              <a:t>2. Procurement Agent</a:t>
+            </a:r>
+            <a:endParaRPr lang="en-US" sz="1000" dirty="0"/>
+          </a:p>
+        </p:txBody>
+      </p:sp>
+      <p:sp>
+        <p:nvSpPr>
+          <p:cNvPr id="34" name="Text 32"/>
+          <p:cNvSpPr txBox="1"/>
+          <p:nvPr/>
+        </p:nvSpPr>
+        <p:spPr>
+          <a:xfrm>
+            <a:off x="5102352" y="3054096"/>
+            <a:ext cx="1965960" cy="201168"/>
+          </a:xfrm>
+          <a:prstGeom prst="rect">
+            <a:avLst/>
+          </a:prstGeom>
+          <a:noFill/>
+          <a:ln/>
+        </p:spPr>
+        <p:txBody>
+          <a:bodyPr wrap="square" lIns="25400" tIns="25400" rIns="25400" bIns="25400" rtlCol="0" anchor="ctr"/>
+          <a:lstStyle/>
+          <a:p>
+            <a:pPr algn="ctr" indent="0" marL="0">
+              <a:buNone/>
+            </a:pPr>
+            <a:r>
+              <a:rPr lang="en-US" sz="800" dirty="0">
+                <a:solidFill>
+                  <a:srgbClr val="6D28D9"/>
+                </a:solidFill>
+                <a:latin typeface="Calibri" pitchFamily="34" charset="0"/>
+                <a:ea typeface="Calibri" pitchFamily="34" charset="-122"/>
+                <a:cs typeface="Calibri" pitchFamily="34" charset="-120"/>
+              </a:rPr>
+              <a:t>(Quote &amp; Place PO)</a:t>
+            </a:r>
+            <a:endParaRPr lang="en-US" sz="800" dirty="0"/>
+          </a:p>
+        </p:txBody>
+      </p:sp>
+      <p:sp>
+        <p:nvSpPr>
+          <p:cNvPr id="35" name="Shape 33"/>
+          <p:cNvSpPr/>
+          <p:nvPr/>
+        </p:nvSpPr>
+        <p:spPr>
+          <a:xfrm>
+            <a:off x="5148072" y="3310128"/>
+            <a:ext cx="1874520" cy="960120"/>
+          </a:xfrm>
+          <a:prstGeom prst="rect">
+            <a:avLst/>
+          </a:prstGeom>
+          <a:solidFill>
+            <a:srgbClr val="FFFFFF"/>
+          </a:solidFill>
+          <a:ln w="12700">
+            <a:solidFill>
+              <a:srgbClr val="D6E0F5"/>
+            </a:solidFill>
+            <a:prstDash val="solid"/>
+          </a:ln>
+        </p:spPr>
+      </p:sp>
+      <p:sp>
+        <p:nvSpPr>
+          <p:cNvPr id="36" name="Text 34"/>
+          <p:cNvSpPr txBox="1"/>
+          <p:nvPr/>
+        </p:nvSpPr>
+        <p:spPr>
+          <a:xfrm>
+            <a:off x="5193792" y="3346704"/>
+            <a:ext cx="1783080" cy="886968"/>
+          </a:xfrm>
+          <a:prstGeom prst="rect">
+            <a:avLst/>
+          </a:prstGeom>
+          <a:noFill/>
+          <a:ln/>
+        </p:spPr>
+        <p:txBody>
+          <a:bodyPr wrap="square" lIns="25400" tIns="25400" rIns="25400" bIns="25400" rtlCol="0" anchor="ctr"/>
+          <a:lstStyle/>
+          <a:p>
+            <a:pPr marL="342900" indent="-342900">
+              <a:buSzPct val="100000"/>
+              <a:buChar char="•"/>
+            </a:pPr>
+            <a:r>
+              <a:rPr lang="en-US" sz="850" dirty="0">
                 <a:solidFill>
                   <a:srgbClr val="1E293B"/>
                 </a:solidFill>
@@ -2677,30 +2983,64 @@
                 <a:ea typeface="Calibri" pitchFamily="34" charset="-122"/>
                 <a:cs typeface="Calibri" pitchFamily="34" charset="-120"/>
               </a:rPr>
-              <a:t>State Coordination</a:t>
-            </a:r>
-            <a:endParaRPr lang="en-US" sz="800" dirty="0"/>
-          </a:p>
-        </p:txBody>
-      </p:sp>
-      <p:sp>
-        <p:nvSpPr>
-          <p:cNvPr id="29" name="Shape 27"/>
+              <a:t>Fetch vendor quotes</a:t>
+            </a:r>
+            <a:endParaRPr lang="en-US" sz="850" dirty="0"/>
+          </a:p>
+          <a:p>
+            <a:pPr marL="342900" indent="-342900">
+              <a:buSzPct val="100000"/>
+              <a:buChar char="•"/>
+            </a:pPr>
+            <a:r>
+              <a:rPr lang="en-US" sz="850" dirty="0">
+                <a:solidFill>
+                  <a:srgbClr val="1E293B"/>
+                </a:solidFill>
+                <a:latin typeface="Calibri" pitchFamily="34" charset="0"/>
+                <a:ea typeface="Calibri" pitchFamily="34" charset="-122"/>
+                <a:cs typeface="Calibri" pitchFamily="34" charset="-120"/>
+              </a:rPr>
+              <a:t>Rank on price &amp; lead time</a:t>
+            </a:r>
+            <a:endParaRPr lang="en-US" sz="850" dirty="0"/>
+          </a:p>
+          <a:p>
+            <a:pPr marL="342900" indent="-342900">
+              <a:buSzPct val="100000"/>
+              <a:buChar char="•"/>
+            </a:pPr>
+            <a:r>
+              <a:rPr lang="en-US" sz="850" dirty="0">
+                <a:solidFill>
+                  <a:srgbClr val="1E293B"/>
+                </a:solidFill>
+                <a:latin typeface="Calibri" pitchFamily="34" charset="0"/>
+                <a:ea typeface="Calibri" pitchFamily="34" charset="-122"/>
+                <a:cs typeface="Calibri" pitchFamily="34" charset="-120"/>
+              </a:rPr>
+              <a:t>Place PO only if approved</a:t>
+            </a:r>
+            <a:endParaRPr lang="en-US" sz="850" dirty="0"/>
+          </a:p>
+        </p:txBody>
+      </p:sp>
+      <p:sp>
+        <p:nvSpPr>
+          <p:cNvPr id="37" name="Shape 35"/>
           <p:cNvSpPr/>
           <p:nvPr/>
         </p:nvSpPr>
         <p:spPr>
           <a:xfrm>
-            <a:off x="6729984" y="1828800"/>
-            <a:ext cx="1188720" cy="411480"/>
-          </a:xfrm>
-          <a:prstGeom prst="roundRect">
-            <a:avLst>
-              <a:gd name="adj" fmla="val 13333"/>
-            </a:avLst>
-          </a:prstGeom>
-          <a:solidFill>
-            <a:srgbClr val="FFFFFF"/>
+            <a:off x="7187184" y="2788920"/>
+            <a:ext cx="2057400" cy="1554480"/>
+          </a:xfrm>
+          <a:prstGeom prst="rect">
+            <a:avLst/>
+          </a:prstGeom>
+          <a:solidFill>
+            <a:srgbClr val="FFF7ED"/>
           </a:solidFill>
           <a:ln w="12700">
             <a:solidFill>
@@ -2712,14 +3052,14 @@
       </p:sp>
       <p:sp>
         <p:nvSpPr>
-          <p:cNvPr id="30" name="Text 28"/>
-          <p:cNvSpPr txBox="1"/>
-          <p:nvPr/>
-        </p:nvSpPr>
-        <p:spPr>
-          <a:xfrm>
-            <a:off x="6775704" y="1865376"/>
-            <a:ext cx="1097280" cy="338328"/>
+          <p:cNvPr id="38" name="Text 36"/>
+          <p:cNvSpPr txBox="1"/>
+          <p:nvPr/>
+        </p:nvSpPr>
+        <p:spPr>
+          <a:xfrm>
+            <a:off x="7232904" y="2816352"/>
+            <a:ext cx="1965960" cy="256032"/>
           </a:xfrm>
           <a:prstGeom prst="rect">
             <a:avLst/>
@@ -2735,15 +3075,54 @@
               <a:buNone/>
             </a:pPr>
             <a:r>
-              <a:rPr lang="en-US" sz="800" b="1" dirty="0">
-                <a:solidFill>
-                  <a:srgbClr val="1E293B"/>
-                </a:solidFill>
-                <a:latin typeface="Calibri" pitchFamily="34" charset="0"/>
-                <a:ea typeface="Calibri" pitchFamily="34" charset="-122"/>
-                <a:cs typeface="Calibri" pitchFamily="34" charset="-120"/>
-              </a:rPr>
-              <a:t>Human Approval Gate</a:t>
+              <a:rPr lang="en-US" sz="1000" b="1" dirty="0">
+                <a:solidFill>
+                  <a:srgbClr val="6D28D9"/>
+                </a:solidFill>
+                <a:latin typeface="Calibri" pitchFamily="34" charset="0"/>
+                <a:ea typeface="Calibri" pitchFamily="34" charset="-122"/>
+                <a:cs typeface="Calibri" pitchFamily="34" charset="-120"/>
+              </a:rPr>
+              <a:t>3. Budget Agent</a:t>
+            </a:r>
+            <a:endParaRPr lang="en-US" sz="1000" dirty="0"/>
+          </a:p>
+        </p:txBody>
+      </p:sp>
+      <p:sp>
+        <p:nvSpPr>
+          <p:cNvPr id="39" name="Text 37"/>
+          <p:cNvSpPr txBox="1"/>
+          <p:nvPr/>
+        </p:nvSpPr>
+        <p:spPr>
+          <a:xfrm>
+            <a:off x="7232904" y="3054096"/>
+            <a:ext cx="1965960" cy="201168"/>
+          </a:xfrm>
+          <a:prstGeom prst="rect">
+            <a:avLst/>
+          </a:prstGeom>
+          <a:noFill/>
+          <a:ln/>
+        </p:spPr>
+        <p:txBody>
+          <a:bodyPr wrap="square" lIns="25400" tIns="25400" rIns="25400" bIns="25400" rtlCol="0" anchor="ctr"/>
+          <a:lstStyle/>
+          <a:p>
+            <a:pPr algn="ctr" indent="0" marL="0">
+              <a:buNone/>
+            </a:pPr>
+            <a:r>
+              <a:rPr lang="en-US" sz="800" dirty="0">
+                <a:solidFill>
+                  <a:srgbClr val="6D28D9"/>
+                </a:solidFill>
+                <a:latin typeface="Calibri" pitchFamily="34" charset="0"/>
+                <a:ea typeface="Calibri" pitchFamily="34" charset="-122"/>
+                <a:cs typeface="Calibri" pitchFamily="34" charset="-120"/>
+              </a:rPr>
+              <a:t>(Validate &amp; Approve - HITL)</a:t>
             </a:r>
             <a:endParaRPr lang="en-US" sz="800" dirty="0"/>
           </a:p>
@@ -2751,273 +3130,13 @@
       </p:sp>
       <p:sp>
         <p:nvSpPr>
-          <p:cNvPr id="31" name="Shape 29"/>
+          <p:cNvPr id="40" name="Shape 38"/>
           <p:cNvSpPr/>
           <p:nvPr/>
         </p:nvSpPr>
         <p:spPr>
           <a:xfrm>
-            <a:off x="7982712" y="1828800"/>
-            <a:ext cx="1188720" cy="411480"/>
-          </a:xfrm>
-          <a:prstGeom prst="roundRect">
-            <a:avLst>
-              <a:gd name="adj" fmla="val 13333"/>
-            </a:avLst>
-          </a:prstGeom>
-          <a:solidFill>
-            <a:srgbClr val="FFFFFF"/>
-          </a:solidFill>
-          <a:ln w="12700">
-            <a:solidFill>
-              <a:srgbClr val="93A8D8"/>
-            </a:solidFill>
-            <a:prstDash val="solid"/>
-          </a:ln>
-        </p:spPr>
-      </p:sp>
-      <p:sp>
-        <p:nvSpPr>
-          <p:cNvPr id="32" name="Text 30"/>
-          <p:cNvSpPr txBox="1"/>
-          <p:nvPr/>
-        </p:nvSpPr>
-        <p:spPr>
-          <a:xfrm>
-            <a:off x="8028432" y="1865376"/>
-            <a:ext cx="1097280" cy="338328"/>
-          </a:xfrm>
-          <a:prstGeom prst="rect">
-            <a:avLst/>
-          </a:prstGeom>
-          <a:noFill/>
-          <a:ln/>
-        </p:spPr>
-        <p:txBody>
-          <a:bodyPr wrap="square" lIns="25400" tIns="25400" rIns="25400" bIns="25400" rtlCol="0" anchor="ctr"/>
-          <a:lstStyle/>
-          <a:p>
-            <a:pPr algn="ctr" indent="0" marL="0">
-              <a:buNone/>
-            </a:pPr>
-            <a:r>
-              <a:rPr lang="en-US" sz="800" b="1" dirty="0">
-                <a:solidFill>
-                  <a:srgbClr val="1E293B"/>
-                </a:solidFill>
-                <a:latin typeface="Calibri" pitchFamily="34" charset="0"/>
-                <a:ea typeface="Calibri" pitchFamily="34" charset="-122"/>
-                <a:cs typeface="Calibri" pitchFamily="34" charset="-120"/>
-              </a:rPr>
-              <a:t>Result Aggregation</a:t>
-            </a:r>
-            <a:endParaRPr lang="en-US" sz="800" dirty="0"/>
-          </a:p>
-        </p:txBody>
-      </p:sp>
-      <p:sp>
-        <p:nvSpPr>
-          <p:cNvPr id="33" name="Shape 31"/>
-          <p:cNvSpPr/>
-          <p:nvPr/>
-        </p:nvSpPr>
-        <p:spPr>
-          <a:xfrm>
-            <a:off x="2834640" y="2560320"/>
-            <a:ext cx="6492240" cy="1874520"/>
-          </a:xfrm>
-          <a:prstGeom prst="rect">
-            <a:avLst/>
-          </a:prstGeom>
-          <a:solidFill>
-            <a:srgbClr val="E8F0FF"/>
-          </a:solidFill>
-          <a:ln w="12700">
-            <a:solidFill>
-              <a:srgbClr val="93A8D8"/>
-            </a:solidFill>
-            <a:prstDash val="dash"/>
-          </a:ln>
-        </p:spPr>
-      </p:sp>
-      <p:sp>
-        <p:nvSpPr>
-          <p:cNvPr id="34" name="Shape 32"/>
-          <p:cNvSpPr/>
-          <p:nvPr/>
-        </p:nvSpPr>
-        <p:spPr>
-          <a:xfrm>
-            <a:off x="2880360" y="2496312"/>
-            <a:ext cx="914400" cy="201168"/>
-          </a:xfrm>
-          <a:prstGeom prst="roundRect">
-            <a:avLst>
-              <a:gd name="adj" fmla="val 22727"/>
-            </a:avLst>
-          </a:prstGeom>
-          <a:solidFill>
-            <a:srgbClr val="2563EB"/>
-          </a:solidFill>
-          <a:ln w="12700">
-            <a:solidFill>
-              <a:srgbClr val="2563EB"/>
-            </a:solidFill>
-            <a:prstDash val="solid"/>
-          </a:ln>
-        </p:spPr>
-      </p:sp>
-      <p:sp>
-        <p:nvSpPr>
-          <p:cNvPr id="35" name="Text 33"/>
-          <p:cNvSpPr txBox="1"/>
-          <p:nvPr/>
-        </p:nvSpPr>
-        <p:spPr>
-          <a:xfrm>
-            <a:off x="2880360" y="2496312"/>
-            <a:ext cx="914400" cy="201168"/>
-          </a:xfrm>
-          <a:prstGeom prst="rect">
-            <a:avLst/>
-          </a:prstGeom>
-          <a:noFill/>
-          <a:ln/>
-        </p:spPr>
-        <p:txBody>
-          <a:bodyPr wrap="square" lIns="25400" tIns="25400" rIns="25400" bIns="25400" rtlCol="0" anchor="ctr"/>
-          <a:lstStyle/>
-          <a:p>
-            <a:pPr algn="ctr" indent="0" marL="0">
-              <a:buNone/>
-            </a:pPr>
-            <a:r>
-              <a:rPr lang="en-US" sz="800" b="1" dirty="0">
-                <a:solidFill>
-                  <a:srgbClr val="FFFFFF"/>
-                </a:solidFill>
-                <a:latin typeface="Calibri" pitchFamily="34" charset="0"/>
-                <a:ea typeface="Calibri" pitchFamily="34" charset="-122"/>
-                <a:cs typeface="Calibri" pitchFamily="34" charset="-120"/>
-              </a:rPr>
-              <a:t>3 Sub Agents</a:t>
-            </a:r>
-            <a:endParaRPr lang="en-US" sz="800" dirty="0"/>
-          </a:p>
-        </p:txBody>
-      </p:sp>
-      <p:sp>
-        <p:nvSpPr>
-          <p:cNvPr id="36" name="Shape 34"/>
-          <p:cNvSpPr/>
-          <p:nvPr/>
-        </p:nvSpPr>
-        <p:spPr>
-          <a:xfrm>
-            <a:off x="2926080" y="2788920"/>
-            <a:ext cx="2057400" cy="1554480"/>
-          </a:xfrm>
-          <a:prstGeom prst="rect">
-            <a:avLst/>
-          </a:prstGeom>
-          <a:solidFill>
-            <a:srgbClr val="F0F7FF"/>
-          </a:solidFill>
-          <a:ln w="12700">
-            <a:solidFill>
-              <a:srgbClr val="93A8D8"/>
-            </a:solidFill>
-            <a:prstDash val="solid"/>
-          </a:ln>
-        </p:spPr>
-      </p:sp>
-      <p:sp>
-        <p:nvSpPr>
-          <p:cNvPr id="37" name="Text 35"/>
-          <p:cNvSpPr txBox="1"/>
-          <p:nvPr/>
-        </p:nvSpPr>
-        <p:spPr>
-          <a:xfrm>
-            <a:off x="2971800" y="2816352"/>
-            <a:ext cx="1965960" cy="256032"/>
-          </a:xfrm>
-          <a:prstGeom prst="rect">
-            <a:avLst/>
-          </a:prstGeom>
-          <a:noFill/>
-          <a:ln/>
-        </p:spPr>
-        <p:txBody>
-          <a:bodyPr wrap="square" lIns="25400" tIns="25400" rIns="25400" bIns="25400" rtlCol="0" anchor="ctr"/>
-          <a:lstStyle/>
-          <a:p>
-            <a:pPr algn="ctr" indent="0" marL="0">
-              <a:buNone/>
-            </a:pPr>
-            <a:r>
-              <a:rPr lang="en-US" sz="1000" b="1" dirty="0">
-                <a:solidFill>
-                  <a:srgbClr val="6D28D9"/>
-                </a:solidFill>
-                <a:latin typeface="Calibri" pitchFamily="34" charset="0"/>
-                <a:ea typeface="Calibri" pitchFamily="34" charset="-122"/>
-                <a:cs typeface="Calibri" pitchFamily="34" charset="-120"/>
-              </a:rPr>
-              <a:t>1. Inventory Agent</a:t>
-            </a:r>
-            <a:endParaRPr lang="en-US" sz="1000" dirty="0"/>
-          </a:p>
-        </p:txBody>
-      </p:sp>
-      <p:sp>
-        <p:nvSpPr>
-          <p:cNvPr id="38" name="Text 36"/>
-          <p:cNvSpPr txBox="1"/>
-          <p:nvPr/>
-        </p:nvSpPr>
-        <p:spPr>
-          <a:xfrm>
-            <a:off x="2971800" y="3054096"/>
-            <a:ext cx="1965960" cy="201168"/>
-          </a:xfrm>
-          <a:prstGeom prst="rect">
-            <a:avLst/>
-          </a:prstGeom>
-          <a:noFill/>
-          <a:ln/>
-        </p:spPr>
-        <p:txBody>
-          <a:bodyPr wrap="square" lIns="25400" tIns="25400" rIns="25400" bIns="25400" rtlCol="0" anchor="ctr"/>
-          <a:lstStyle/>
-          <a:p>
-            <a:pPr algn="ctr" indent="0" marL="0">
-              <a:buNone/>
-            </a:pPr>
-            <a:r>
-              <a:rPr lang="en-US" sz="800" dirty="0">
-                <a:solidFill>
-                  <a:srgbClr val="6D28D9"/>
-                </a:solidFill>
-                <a:latin typeface="Calibri" pitchFamily="34" charset="0"/>
-                <a:ea typeface="Calibri" pitchFamily="34" charset="-122"/>
-                <a:cs typeface="Calibri" pitchFamily="34" charset="-120"/>
-              </a:rPr>
-              <a:t>(Check &amp; Reserve Stock)</a:t>
-            </a:r>
-            <a:endParaRPr lang="en-US" sz="800" dirty="0"/>
-          </a:p>
-        </p:txBody>
-      </p:sp>
-      <p:sp>
-        <p:nvSpPr>
-          <p:cNvPr id="39" name="Shape 37"/>
-          <p:cNvSpPr/>
-          <p:nvPr/>
-        </p:nvSpPr>
-        <p:spPr>
-          <a:xfrm>
-            <a:off x="3017520" y="3310128"/>
+            <a:off x="7278624" y="3310128"/>
             <a:ext cx="1874520" cy="960120"/>
           </a:xfrm>
           <a:prstGeom prst="rect">
@@ -3036,13 +3155,13 @@
       </p:sp>
       <p:sp>
         <p:nvSpPr>
-          <p:cNvPr id="40" name="Text 38"/>
-          <p:cNvSpPr txBox="1"/>
-          <p:nvPr/>
-        </p:nvSpPr>
-        <p:spPr>
-          <a:xfrm>
-            <a:off x="3063240" y="3346704"/>
+          <p:cNvPr id="41" name="Text 39"/>
+          <p:cNvSpPr txBox="1"/>
+          <p:nvPr/>
+        </p:nvSpPr>
+        <p:spPr>
+          <a:xfrm>
+            <a:off x="7324344" y="3346704"/>
             <a:ext cx="1783080" cy="886968"/>
           </a:xfrm>
           <a:prstGeom prst="rect">
@@ -3068,7 +3187,7 @@
                 <a:ea typeface="Calibri" pitchFamily="34" charset="-122"/>
                 <a:cs typeface="Calibri" pitchFamily="34" charset="-120"/>
               </a:rPr>
-              <a:t>Check live stock by SKU</a:t>
+              <a:t>Check remaining budget</a:t>
             </a:r>
             <a:endParaRPr lang="en-US" sz="850" dirty="0"/>
           </a:p>
@@ -3086,7 +3205,7 @@
                 <a:ea typeface="Calibri" pitchFamily="34" charset="-122"/>
                 <a:cs typeface="Calibri" pitchFamily="34" charset="-120"/>
               </a:rPr>
-              <a:t>Reserve available units</a:t>
+              <a:t>Auto-approve under threshold</a:t>
             </a:r>
             <a:endParaRPr lang="en-US" sz="850" dirty="0"/>
           </a:p>
@@ -3104,7 +3223,7 @@
                 <a:ea typeface="Calibri" pitchFamily="34" charset="-122"/>
                 <a:cs typeface="Calibri" pitchFamily="34" charset="-120"/>
               </a:rPr>
-              <a:t>Report shortfall to procure</a:t>
+              <a:t>Human approval above threshold</a:t>
             </a:r>
             <a:endParaRPr lang="en-US" sz="850" dirty="0"/>
           </a:p>
@@ -3112,415 +3231,7 @@
       </p:sp>
       <p:sp>
         <p:nvSpPr>
-          <p:cNvPr id="41" name="Shape 39"/>
-          <p:cNvSpPr/>
-          <p:nvPr/>
-        </p:nvSpPr>
-        <p:spPr>
-          <a:xfrm>
-            <a:off x="5056632" y="2788920"/>
-            <a:ext cx="2057400" cy="1554480"/>
-          </a:xfrm>
-          <a:prstGeom prst="rect">
-            <a:avLst/>
-          </a:prstGeom>
-          <a:solidFill>
-            <a:srgbClr val="F3EEFF"/>
-          </a:solidFill>
-          <a:ln w="12700">
-            <a:solidFill>
-              <a:srgbClr val="93A8D8"/>
-            </a:solidFill>
-            <a:prstDash val="solid"/>
-          </a:ln>
-        </p:spPr>
-      </p:sp>
-      <p:sp>
-        <p:nvSpPr>
-          <p:cNvPr id="42" name="Text 40"/>
-          <p:cNvSpPr txBox="1"/>
-          <p:nvPr/>
-        </p:nvSpPr>
-        <p:spPr>
-          <a:xfrm>
-            <a:off x="5102352" y="2816352"/>
-            <a:ext cx="1965960" cy="256032"/>
-          </a:xfrm>
-          <a:prstGeom prst="rect">
-            <a:avLst/>
-          </a:prstGeom>
-          <a:noFill/>
-          <a:ln/>
-        </p:spPr>
-        <p:txBody>
-          <a:bodyPr wrap="square" lIns="25400" tIns="25400" rIns="25400" bIns="25400" rtlCol="0" anchor="ctr"/>
-          <a:lstStyle/>
-          <a:p>
-            <a:pPr algn="ctr" indent="0" marL="0">
-              <a:buNone/>
-            </a:pPr>
-            <a:r>
-              <a:rPr lang="en-US" sz="1000" b="1" dirty="0">
-                <a:solidFill>
-                  <a:srgbClr val="6D28D9"/>
-                </a:solidFill>
-                <a:latin typeface="Calibri" pitchFamily="34" charset="0"/>
-                <a:ea typeface="Calibri" pitchFamily="34" charset="-122"/>
-                <a:cs typeface="Calibri" pitchFamily="34" charset="-120"/>
-              </a:rPr>
-              <a:t>2. Procurement Agent</a:t>
-            </a:r>
-            <a:endParaRPr lang="en-US" sz="1000" dirty="0"/>
-          </a:p>
-        </p:txBody>
-      </p:sp>
-      <p:sp>
-        <p:nvSpPr>
-          <p:cNvPr id="43" name="Text 41"/>
-          <p:cNvSpPr txBox="1"/>
-          <p:nvPr/>
-        </p:nvSpPr>
-        <p:spPr>
-          <a:xfrm>
-            <a:off x="5102352" y="3054096"/>
-            <a:ext cx="1965960" cy="201168"/>
-          </a:xfrm>
-          <a:prstGeom prst="rect">
-            <a:avLst/>
-          </a:prstGeom>
-          <a:noFill/>
-          <a:ln/>
-        </p:spPr>
-        <p:txBody>
-          <a:bodyPr wrap="square" lIns="25400" tIns="25400" rIns="25400" bIns="25400" rtlCol="0" anchor="ctr"/>
-          <a:lstStyle/>
-          <a:p>
-            <a:pPr algn="ctr" indent="0" marL="0">
-              <a:buNone/>
-            </a:pPr>
-            <a:r>
-              <a:rPr lang="en-US" sz="800" dirty="0">
-                <a:solidFill>
-                  <a:srgbClr val="6D28D9"/>
-                </a:solidFill>
-                <a:latin typeface="Calibri" pitchFamily="34" charset="0"/>
-                <a:ea typeface="Calibri" pitchFamily="34" charset="-122"/>
-                <a:cs typeface="Calibri" pitchFamily="34" charset="-120"/>
-              </a:rPr>
-              <a:t>(Quote &amp; Place PO)</a:t>
-            </a:r>
-            <a:endParaRPr lang="en-US" sz="800" dirty="0"/>
-          </a:p>
-        </p:txBody>
-      </p:sp>
-      <p:sp>
-        <p:nvSpPr>
-          <p:cNvPr id="44" name="Shape 42"/>
-          <p:cNvSpPr/>
-          <p:nvPr/>
-        </p:nvSpPr>
-        <p:spPr>
-          <a:xfrm>
-            <a:off x="5148072" y="3310128"/>
-            <a:ext cx="1874520" cy="960120"/>
-          </a:xfrm>
-          <a:prstGeom prst="rect">
-            <a:avLst/>
-          </a:prstGeom>
-          <a:solidFill>
-            <a:srgbClr val="FFFFFF"/>
-          </a:solidFill>
-          <a:ln w="12700">
-            <a:solidFill>
-              <a:srgbClr val="D6E0F5"/>
-            </a:solidFill>
-            <a:prstDash val="solid"/>
-          </a:ln>
-        </p:spPr>
-      </p:sp>
-      <p:sp>
-        <p:nvSpPr>
-          <p:cNvPr id="45" name="Text 43"/>
-          <p:cNvSpPr txBox="1"/>
-          <p:nvPr/>
-        </p:nvSpPr>
-        <p:spPr>
-          <a:xfrm>
-            <a:off x="5193792" y="3346704"/>
-            <a:ext cx="1783080" cy="886968"/>
-          </a:xfrm>
-          <a:prstGeom prst="rect">
-            <a:avLst/>
-          </a:prstGeom>
-          <a:noFill/>
-          <a:ln/>
-        </p:spPr>
-        <p:txBody>
-          <a:bodyPr wrap="square" lIns="25400" tIns="25400" rIns="25400" bIns="25400" rtlCol="0" anchor="ctr"/>
-          <a:lstStyle/>
-          <a:p>
-            <a:pPr marL="342900" indent="-342900">
-              <a:buSzPct val="100000"/>
-              <a:buChar char="•"/>
-            </a:pPr>
-            <a:r>
-              <a:rPr lang="en-US" sz="850" dirty="0">
-                <a:solidFill>
-                  <a:srgbClr val="1E293B"/>
-                </a:solidFill>
-                <a:latin typeface="Calibri" pitchFamily="34" charset="0"/>
-                <a:ea typeface="Calibri" pitchFamily="34" charset="-122"/>
-                <a:cs typeface="Calibri" pitchFamily="34" charset="-120"/>
-              </a:rPr>
-              <a:t>Fetch vendor quotes</a:t>
-            </a:r>
-            <a:endParaRPr lang="en-US" sz="850" dirty="0"/>
-          </a:p>
-          <a:p>
-            <a:pPr marL="342900" indent="-342900">
-              <a:buSzPct val="100000"/>
-              <a:buChar char="•"/>
-            </a:pPr>
-            <a:r>
-              <a:rPr lang="en-US" sz="850" dirty="0">
-                <a:solidFill>
-                  <a:srgbClr val="1E293B"/>
-                </a:solidFill>
-                <a:latin typeface="Calibri" pitchFamily="34" charset="0"/>
-                <a:ea typeface="Calibri" pitchFamily="34" charset="-122"/>
-                <a:cs typeface="Calibri" pitchFamily="34" charset="-120"/>
-              </a:rPr>
-              <a:t>Rank on price &amp; lead time</a:t>
-            </a:r>
-            <a:endParaRPr lang="en-US" sz="850" dirty="0"/>
-          </a:p>
-          <a:p>
-            <a:pPr marL="342900" indent="-342900">
-              <a:buSzPct val="100000"/>
-              <a:buChar char="•"/>
-            </a:pPr>
-            <a:r>
-              <a:rPr lang="en-US" sz="850" dirty="0">
-                <a:solidFill>
-                  <a:srgbClr val="1E293B"/>
-                </a:solidFill>
-                <a:latin typeface="Calibri" pitchFamily="34" charset="0"/>
-                <a:ea typeface="Calibri" pitchFamily="34" charset="-122"/>
-                <a:cs typeface="Calibri" pitchFamily="34" charset="-120"/>
-              </a:rPr>
-              <a:t>Place PO only if approved</a:t>
-            </a:r>
-            <a:endParaRPr lang="en-US" sz="850" dirty="0"/>
-          </a:p>
-        </p:txBody>
-      </p:sp>
-      <p:sp>
-        <p:nvSpPr>
-          <p:cNvPr id="46" name="Shape 44"/>
-          <p:cNvSpPr/>
-          <p:nvPr/>
-        </p:nvSpPr>
-        <p:spPr>
-          <a:xfrm>
-            <a:off x="7187184" y="2788920"/>
-            <a:ext cx="2057400" cy="1554480"/>
-          </a:xfrm>
-          <a:prstGeom prst="rect">
-            <a:avLst/>
-          </a:prstGeom>
-          <a:solidFill>
-            <a:srgbClr val="FFF7ED"/>
-          </a:solidFill>
-          <a:ln w="12700">
-            <a:solidFill>
-              <a:srgbClr val="93A8D8"/>
-            </a:solidFill>
-            <a:prstDash val="solid"/>
-          </a:ln>
-        </p:spPr>
-      </p:sp>
-      <p:sp>
-        <p:nvSpPr>
-          <p:cNvPr id="47" name="Text 45"/>
-          <p:cNvSpPr txBox="1"/>
-          <p:nvPr/>
-        </p:nvSpPr>
-        <p:spPr>
-          <a:xfrm>
-            <a:off x="7232904" y="2816352"/>
-            <a:ext cx="1965960" cy="256032"/>
-          </a:xfrm>
-          <a:prstGeom prst="rect">
-            <a:avLst/>
-          </a:prstGeom>
-          <a:noFill/>
-          <a:ln/>
-        </p:spPr>
-        <p:txBody>
-          <a:bodyPr wrap="square" lIns="25400" tIns="25400" rIns="25400" bIns="25400" rtlCol="0" anchor="ctr"/>
-          <a:lstStyle/>
-          <a:p>
-            <a:pPr algn="ctr" indent="0" marL="0">
-              <a:buNone/>
-            </a:pPr>
-            <a:r>
-              <a:rPr lang="en-US" sz="1000" b="1" dirty="0">
-                <a:solidFill>
-                  <a:srgbClr val="6D28D9"/>
-                </a:solidFill>
-                <a:latin typeface="Calibri" pitchFamily="34" charset="0"/>
-                <a:ea typeface="Calibri" pitchFamily="34" charset="-122"/>
-                <a:cs typeface="Calibri" pitchFamily="34" charset="-120"/>
-              </a:rPr>
-              <a:t>3. Budget Agent</a:t>
-            </a:r>
-            <a:endParaRPr lang="en-US" sz="1000" dirty="0"/>
-          </a:p>
-        </p:txBody>
-      </p:sp>
-      <p:sp>
-        <p:nvSpPr>
-          <p:cNvPr id="48" name="Text 46"/>
-          <p:cNvSpPr txBox="1"/>
-          <p:nvPr/>
-        </p:nvSpPr>
-        <p:spPr>
-          <a:xfrm>
-            <a:off x="7232904" y="3054096"/>
-            <a:ext cx="1965960" cy="201168"/>
-          </a:xfrm>
-          <a:prstGeom prst="rect">
-            <a:avLst/>
-          </a:prstGeom>
-          <a:noFill/>
-          <a:ln/>
-        </p:spPr>
-        <p:txBody>
-          <a:bodyPr wrap="square" lIns="25400" tIns="25400" rIns="25400" bIns="25400" rtlCol="0" anchor="ctr"/>
-          <a:lstStyle/>
-          <a:p>
-            <a:pPr algn="ctr" indent="0" marL="0">
-              <a:buNone/>
-            </a:pPr>
-            <a:r>
-              <a:rPr lang="en-US" sz="800" dirty="0">
-                <a:solidFill>
-                  <a:srgbClr val="6D28D9"/>
-                </a:solidFill>
-                <a:latin typeface="Calibri" pitchFamily="34" charset="0"/>
-                <a:ea typeface="Calibri" pitchFamily="34" charset="-122"/>
-                <a:cs typeface="Calibri" pitchFamily="34" charset="-120"/>
-              </a:rPr>
-              <a:t>(Validate &amp; Approve - HITL)</a:t>
-            </a:r>
-            <a:endParaRPr lang="en-US" sz="800" dirty="0"/>
-          </a:p>
-        </p:txBody>
-      </p:sp>
-      <p:sp>
-        <p:nvSpPr>
-          <p:cNvPr id="49" name="Shape 47"/>
-          <p:cNvSpPr/>
-          <p:nvPr/>
-        </p:nvSpPr>
-        <p:spPr>
-          <a:xfrm>
-            <a:off x="7278624" y="3310128"/>
-            <a:ext cx="1874520" cy="960120"/>
-          </a:xfrm>
-          <a:prstGeom prst="rect">
-            <a:avLst/>
-          </a:prstGeom>
-          <a:solidFill>
-            <a:srgbClr val="FFFFFF"/>
-          </a:solidFill>
-          <a:ln w="12700">
-            <a:solidFill>
-              <a:srgbClr val="D6E0F5"/>
-            </a:solidFill>
-            <a:prstDash val="solid"/>
-          </a:ln>
-        </p:spPr>
-      </p:sp>
-      <p:sp>
-        <p:nvSpPr>
-          <p:cNvPr id="50" name="Text 48"/>
-          <p:cNvSpPr txBox="1"/>
-          <p:nvPr/>
-        </p:nvSpPr>
-        <p:spPr>
-          <a:xfrm>
-            <a:off x="7324344" y="3346704"/>
-            <a:ext cx="1783080" cy="886968"/>
-          </a:xfrm>
-          <a:prstGeom prst="rect">
-            <a:avLst/>
-          </a:prstGeom>
-          <a:noFill/>
-          <a:ln/>
-        </p:spPr>
-        <p:txBody>
-          <a:bodyPr wrap="square" lIns="25400" tIns="25400" rIns="25400" bIns="25400" rtlCol="0" anchor="ctr"/>
-          <a:lstStyle/>
-          <a:p>
-            <a:pPr marL="342900" indent="-342900">
-              <a:buSzPct val="100000"/>
-              <a:buChar char="•"/>
-            </a:pPr>
-            <a:r>
-              <a:rPr lang="en-US" sz="850" dirty="0">
-                <a:solidFill>
-                  <a:srgbClr val="1E293B"/>
-                </a:solidFill>
-                <a:latin typeface="Calibri" pitchFamily="34" charset="0"/>
-                <a:ea typeface="Calibri" pitchFamily="34" charset="-122"/>
-                <a:cs typeface="Calibri" pitchFamily="34" charset="-120"/>
-              </a:rPr>
-              <a:t>Check remaining budget</a:t>
-            </a:r>
-            <a:endParaRPr lang="en-US" sz="850" dirty="0"/>
-          </a:p>
-          <a:p>
-            <a:pPr marL="342900" indent="-342900">
-              <a:buSzPct val="100000"/>
-              <a:buChar char="•"/>
-            </a:pPr>
-            <a:r>
-              <a:rPr lang="en-US" sz="850" dirty="0">
-                <a:solidFill>
-                  <a:srgbClr val="1E293B"/>
-                </a:solidFill>
-                <a:latin typeface="Calibri" pitchFamily="34" charset="0"/>
-                <a:ea typeface="Calibri" pitchFamily="34" charset="-122"/>
-                <a:cs typeface="Calibri" pitchFamily="34" charset="-120"/>
-              </a:rPr>
-              <a:t>Auto-approve under threshold</a:t>
-            </a:r>
-            <a:endParaRPr lang="en-US" sz="850" dirty="0"/>
-          </a:p>
-          <a:p>
-            <a:pPr marL="342900" indent="-342900">
-              <a:buSzPct val="100000"/>
-              <a:buChar char="•"/>
-            </a:pPr>
-            <a:r>
-              <a:rPr lang="en-US" sz="850" dirty="0">
-                <a:solidFill>
-                  <a:srgbClr val="1E293B"/>
-                </a:solidFill>
-                <a:latin typeface="Calibri" pitchFamily="34" charset="0"/>
-                <a:ea typeface="Calibri" pitchFamily="34" charset="-122"/>
-                <a:cs typeface="Calibri" pitchFamily="34" charset="-120"/>
-              </a:rPr>
-              <a:t>Human approval above threshold</a:t>
-            </a:r>
-            <a:endParaRPr lang="en-US" sz="850" dirty="0"/>
-          </a:p>
-        </p:txBody>
-      </p:sp>
-      <p:sp>
-        <p:nvSpPr>
-          <p:cNvPr id="51" name="Shape 49"/>
+          <p:cNvPr id="42" name="Shape 40"/>
           <p:cNvSpPr/>
           <p:nvPr/>
         </p:nvSpPr>
@@ -3545,7 +3256,7 @@
       </p:sp>
       <p:sp>
         <p:nvSpPr>
-          <p:cNvPr id="52" name="Shape 50"/>
+          <p:cNvPr id="43" name="Shape 41"/>
           <p:cNvSpPr/>
           <p:nvPr/>
         </p:nvSpPr>
@@ -3570,7 +3281,7 @@
       </p:sp>
       <p:sp>
         <p:nvSpPr>
-          <p:cNvPr id="53" name="Text 51"/>
+          <p:cNvPr id="44" name="Text 42"/>
           <p:cNvSpPr txBox="1"/>
           <p:nvPr/>
         </p:nvSpPr>
@@ -3609,7 +3320,7 @@
       </p:sp>
       <p:sp>
         <p:nvSpPr>
-          <p:cNvPr id="54" name="Shape 52"/>
+          <p:cNvPr id="45" name="Shape 43"/>
           <p:cNvSpPr/>
           <p:nvPr/>
         </p:nvSpPr>
@@ -3636,7 +3347,7 @@
       </p:sp>
       <p:sp>
         <p:nvSpPr>
-          <p:cNvPr id="55" name="Text 53"/>
+          <p:cNvPr id="46" name="Text 44"/>
           <p:cNvSpPr txBox="1"/>
           <p:nvPr/>
         </p:nvSpPr>
@@ -3675,7 +3386,7 @@
       </p:sp>
       <p:sp>
         <p:nvSpPr>
-          <p:cNvPr id="56" name="Text 54"/>
+          <p:cNvPr id="47" name="Text 45"/>
           <p:cNvSpPr txBox="1"/>
           <p:nvPr/>
         </p:nvSpPr>
@@ -3714,7 +3425,7 @@
       </p:sp>
       <p:sp>
         <p:nvSpPr>
-          <p:cNvPr id="57" name="Shape 55"/>
+          <p:cNvPr id="48" name="Shape 46"/>
           <p:cNvSpPr/>
           <p:nvPr/>
         </p:nvSpPr>
@@ -3741,7 +3452,7 @@
       </p:sp>
       <p:sp>
         <p:nvSpPr>
-          <p:cNvPr id="58" name="Text 56"/>
+          <p:cNvPr id="49" name="Text 47"/>
           <p:cNvSpPr txBox="1"/>
           <p:nvPr/>
         </p:nvSpPr>
@@ -3780,7 +3491,7 @@
       </p:sp>
       <p:sp>
         <p:nvSpPr>
-          <p:cNvPr id="59" name="Text 57"/>
+          <p:cNvPr id="50" name="Text 48"/>
           <p:cNvSpPr txBox="1"/>
           <p:nvPr/>
         </p:nvSpPr>
@@ -3819,7 +3530,7 @@
       </p:sp>
       <p:sp>
         <p:nvSpPr>
-          <p:cNvPr id="60" name="Shape 58"/>
+          <p:cNvPr id="51" name="Shape 49"/>
           <p:cNvSpPr/>
           <p:nvPr/>
         </p:nvSpPr>
@@ -3846,7 +3557,7 @@
       </p:sp>
       <p:sp>
         <p:nvSpPr>
-          <p:cNvPr id="61" name="Text 59"/>
+          <p:cNvPr id="52" name="Text 50"/>
           <p:cNvSpPr txBox="1"/>
           <p:nvPr/>
         </p:nvSpPr>
@@ -3885,7 +3596,7 @@
       </p:sp>
       <p:sp>
         <p:nvSpPr>
-          <p:cNvPr id="62" name="Text 60"/>
+          <p:cNvPr id="53" name="Text 51"/>
           <p:cNvSpPr txBox="1"/>
           <p:nvPr/>
         </p:nvSpPr>
@@ -3924,7 +3635,7 @@
       </p:sp>
       <p:sp>
         <p:nvSpPr>
-          <p:cNvPr id="63" name="Shape 61"/>
+          <p:cNvPr id="54" name="Shape 52"/>
           <p:cNvSpPr/>
           <p:nvPr/>
         </p:nvSpPr>
@@ -3949,7 +3660,7 @@
       </p:sp>
       <p:sp>
         <p:nvSpPr>
-          <p:cNvPr id="64" name="Text 62"/>
+          <p:cNvPr id="55" name="Text 53"/>
           <p:cNvSpPr txBox="1"/>
           <p:nvPr/>
         </p:nvSpPr>
@@ -3988,7 +3699,7 @@
       </p:sp>
       <p:sp>
         <p:nvSpPr>
-          <p:cNvPr id="65" name="Shape 63"/>
+          <p:cNvPr id="56" name="Shape 54"/>
           <p:cNvSpPr/>
           <p:nvPr/>
         </p:nvSpPr>
@@ -4015,7 +3726,7 @@
       </p:sp>
       <p:sp>
         <p:nvSpPr>
-          <p:cNvPr id="66" name="Text 64"/>
+          <p:cNvPr id="57" name="Text 55"/>
           <p:cNvSpPr txBox="1"/>
           <p:nvPr/>
         </p:nvSpPr>
@@ -4054,7 +3765,7 @@
       </p:sp>
       <p:sp>
         <p:nvSpPr>
-          <p:cNvPr id="67" name="Text 65"/>
+          <p:cNvPr id="58" name="Text 56"/>
           <p:cNvSpPr txBox="1"/>
           <p:nvPr/>
         </p:nvSpPr>
@@ -4093,7 +3804,7 @@
       </p:sp>
       <p:sp>
         <p:nvSpPr>
-          <p:cNvPr id="68" name="Shape 66"/>
+          <p:cNvPr id="59" name="Shape 57"/>
           <p:cNvSpPr/>
           <p:nvPr/>
         </p:nvSpPr>
@@ -4120,7 +3831,7 @@
       </p:sp>
       <p:sp>
         <p:nvSpPr>
-          <p:cNvPr id="69" name="Text 67"/>
+          <p:cNvPr id="60" name="Text 58"/>
           <p:cNvSpPr txBox="1"/>
           <p:nvPr/>
         </p:nvSpPr>
@@ -4159,7 +3870,7 @@
       </p:sp>
       <p:sp>
         <p:nvSpPr>
-          <p:cNvPr id="70" name="Text 68"/>
+          <p:cNvPr id="61" name="Text 59"/>
           <p:cNvSpPr txBox="1"/>
           <p:nvPr/>
         </p:nvSpPr>
@@ -4198,7 +3909,7 @@
       </p:sp>
       <p:sp>
         <p:nvSpPr>
-          <p:cNvPr id="71" name="Shape 69"/>
+          <p:cNvPr id="62" name="Shape 60"/>
           <p:cNvSpPr/>
           <p:nvPr/>
         </p:nvSpPr>
@@ -4225,7 +3936,7 @@
       </p:sp>
       <p:sp>
         <p:nvSpPr>
-          <p:cNvPr id="72" name="Text 70"/>
+          <p:cNvPr id="63" name="Text 61"/>
           <p:cNvSpPr txBox="1"/>
           <p:nvPr/>
         </p:nvSpPr>
@@ -4264,7 +3975,7 @@
       </p:sp>
       <p:sp>
         <p:nvSpPr>
-          <p:cNvPr id="73" name="Text 71"/>
+          <p:cNvPr id="64" name="Text 62"/>
           <p:cNvSpPr txBox="1"/>
           <p:nvPr/>
         </p:nvSpPr>
@@ -4303,7 +4014,7 @@
       </p:sp>
       <p:sp>
         <p:nvSpPr>
-          <p:cNvPr id="74" name="Shape 72"/>
+          <p:cNvPr id="65" name="Shape 63"/>
           <p:cNvSpPr/>
           <p:nvPr/>
         </p:nvSpPr>
@@ -4330,7 +4041,7 @@
       </p:sp>
       <p:sp>
         <p:nvSpPr>
-          <p:cNvPr id="75" name="Text 73"/>
+          <p:cNvPr id="66" name="Text 64"/>
           <p:cNvSpPr txBox="1"/>
           <p:nvPr/>
         </p:nvSpPr>
@@ -4369,7 +4080,7 @@
       </p:sp>
       <p:sp>
         <p:nvSpPr>
-          <p:cNvPr id="76" name="Text 74"/>
+          <p:cNvPr id="67" name="Text 65"/>
           <p:cNvSpPr txBox="1"/>
           <p:nvPr/>
         </p:nvSpPr>
@@ -4408,7 +4119,7 @@
       </p:sp>
       <p:sp>
         <p:nvSpPr>
-          <p:cNvPr id="77" name="Shape 75"/>
+          <p:cNvPr id="68" name="Shape 66"/>
           <p:cNvSpPr/>
           <p:nvPr/>
         </p:nvSpPr>
@@ -4435,7 +4146,7 @@
       </p:sp>
       <p:sp>
         <p:nvSpPr>
-          <p:cNvPr id="78" name="Text 76"/>
+          <p:cNvPr id="69" name="Text 67"/>
           <p:cNvSpPr txBox="1"/>
           <p:nvPr/>
         </p:nvSpPr>
@@ -4474,7 +4185,7 @@
       </p:sp>
       <p:sp>
         <p:nvSpPr>
-          <p:cNvPr id="79" name="Text 77"/>
+          <p:cNvPr id="70" name="Text 68"/>
           <p:cNvSpPr txBox="1"/>
           <p:nvPr/>
         </p:nvSpPr>
@@ -4513,7 +4224,7 @@
       </p:sp>
       <p:sp>
         <p:nvSpPr>
-          <p:cNvPr id="80" name="Shape 78"/>
+          <p:cNvPr id="71" name="Shape 69"/>
           <p:cNvSpPr/>
           <p:nvPr/>
         </p:nvSpPr>
@@ -4540,7 +4251,7 @@
       </p:sp>
       <p:sp>
         <p:nvSpPr>
-          <p:cNvPr id="81" name="Text 79"/>
+          <p:cNvPr id="72" name="Text 70"/>
           <p:cNvSpPr txBox="1"/>
           <p:nvPr/>
         </p:nvSpPr>
@@ -4579,7 +4290,7 @@
       </p:sp>
       <p:sp>
         <p:nvSpPr>
-          <p:cNvPr id="82" name="Text 80"/>
+          <p:cNvPr id="73" name="Text 71"/>
           <p:cNvSpPr txBox="1"/>
           <p:nvPr/>
         </p:nvSpPr>
@@ -4618,7 +4329,7 @@
       </p:sp>
       <p:sp>
         <p:nvSpPr>
-          <p:cNvPr id="83" name="Shape 81"/>
+          <p:cNvPr id="74" name="Shape 72"/>
           <p:cNvSpPr/>
           <p:nvPr/>
         </p:nvSpPr>
@@ -4645,7 +4356,7 @@
       </p:sp>
       <p:sp>
         <p:nvSpPr>
-          <p:cNvPr id="84" name="Text 82"/>
+          <p:cNvPr id="75" name="Text 73"/>
           <p:cNvSpPr txBox="1"/>
           <p:nvPr/>
         </p:nvSpPr>
@@ -4684,7 +4395,7 @@
       </p:sp>
       <p:sp>
         <p:nvSpPr>
-          <p:cNvPr id="85" name="Shape 83"/>
+          <p:cNvPr id="76" name="Shape 74"/>
           <p:cNvSpPr/>
           <p:nvPr/>
         </p:nvSpPr>
@@ -4709,7 +4420,7 @@
       </p:sp>
       <p:sp>
         <p:nvSpPr>
-          <p:cNvPr id="86" name="Shape 84"/>
+          <p:cNvPr id="77" name="Shape 75"/>
           <p:cNvSpPr/>
           <p:nvPr/>
         </p:nvSpPr>
@@ -4734,7 +4445,7 @@
       </p:sp>
       <p:sp>
         <p:nvSpPr>
-          <p:cNvPr id="87" name="Text 85"/>
+          <p:cNvPr id="78" name="Text 76"/>
           <p:cNvSpPr txBox="1"/>
           <p:nvPr/>
         </p:nvSpPr>
@@ -4773,7 +4484,7 @@
       </p:sp>
       <p:sp>
         <p:nvSpPr>
-          <p:cNvPr id="88" name="Shape 86"/>
+          <p:cNvPr id="79" name="Shape 77"/>
           <p:cNvSpPr/>
           <p:nvPr/>
         </p:nvSpPr>
@@ -4800,7 +4511,7 @@
       </p:sp>
       <p:sp>
         <p:nvSpPr>
-          <p:cNvPr id="89" name="Text 87"/>
+          <p:cNvPr id="80" name="Text 78"/>
           <p:cNvSpPr txBox="1"/>
           <p:nvPr/>
         </p:nvSpPr>
@@ -4839,7 +4550,7 @@
       </p:sp>
       <p:sp>
         <p:nvSpPr>
-          <p:cNvPr id="90" name="Text 88"/>
+          <p:cNvPr id="81" name="Text 79"/>
           <p:cNvSpPr txBox="1"/>
           <p:nvPr/>
         </p:nvSpPr>
@@ -4878,7 +4589,7 @@
       </p:sp>
       <p:sp>
         <p:nvSpPr>
-          <p:cNvPr id="91" name="Shape 89"/>
+          <p:cNvPr id="82" name="Shape 80"/>
           <p:cNvSpPr/>
           <p:nvPr/>
         </p:nvSpPr>
@@ -4905,7 +4616,7 @@
       </p:sp>
       <p:sp>
         <p:nvSpPr>
-          <p:cNvPr id="92" name="Text 90"/>
+          <p:cNvPr id="83" name="Text 81"/>
           <p:cNvSpPr txBox="1"/>
           <p:nvPr/>
         </p:nvSpPr>
@@ -4944,7 +4655,7 @@
       </p:sp>
       <p:sp>
         <p:nvSpPr>
-          <p:cNvPr id="93" name="Text 91"/>
+          <p:cNvPr id="84" name="Text 82"/>
           <p:cNvSpPr txBox="1"/>
           <p:nvPr/>
         </p:nvSpPr>
@@ -4983,7 +4694,7 @@
       </p:sp>
       <p:sp>
         <p:nvSpPr>
-          <p:cNvPr id="94" name="Shape 92"/>
+          <p:cNvPr id="85" name="Shape 83"/>
           <p:cNvSpPr/>
           <p:nvPr/>
         </p:nvSpPr>
@@ -5008,7 +4719,7 @@
       </p:sp>
       <p:sp>
         <p:nvSpPr>
-          <p:cNvPr id="95" name="Text 93"/>
+          <p:cNvPr id="86" name="Text 84"/>
           <p:cNvSpPr txBox="1"/>
           <p:nvPr/>
         </p:nvSpPr>
@@ -5047,7 +4758,7 @@
       </p:sp>
       <p:sp>
         <p:nvSpPr>
-          <p:cNvPr id="96" name="Shape 94"/>
+          <p:cNvPr id="87" name="Shape 85"/>
           <p:cNvSpPr/>
           <p:nvPr/>
         </p:nvSpPr>
@@ -5074,7 +4785,7 @@
       </p:sp>
       <p:sp>
         <p:nvSpPr>
-          <p:cNvPr id="97" name="Text 95"/>
+          <p:cNvPr id="88" name="Text 86"/>
           <p:cNvSpPr txBox="1"/>
           <p:nvPr/>
         </p:nvSpPr>
@@ -5113,7 +4824,7 @@
       </p:sp>
       <p:sp>
         <p:nvSpPr>
-          <p:cNvPr id="98" name="Text 96"/>
+          <p:cNvPr id="89" name="Text 87"/>
           <p:cNvSpPr txBox="1"/>
           <p:nvPr/>
         </p:nvSpPr>
@@ -5152,7 +4863,7 @@
       </p:sp>
       <p:sp>
         <p:nvSpPr>
-          <p:cNvPr id="99" name="Shape 97"/>
+          <p:cNvPr id="90" name="Shape 88"/>
           <p:cNvSpPr/>
           <p:nvPr/>
         </p:nvSpPr>
@@ -5179,7 +4890,7 @@
       </p:sp>
       <p:sp>
         <p:nvSpPr>
-          <p:cNvPr id="100" name="Text 98"/>
+          <p:cNvPr id="91" name="Text 89"/>
           <p:cNvSpPr txBox="1"/>
           <p:nvPr/>
         </p:nvSpPr>
@@ -5218,7 +4929,7 @@
       </p:sp>
       <p:sp>
         <p:nvSpPr>
-          <p:cNvPr id="101" name="Text 99"/>
+          <p:cNvPr id="92" name="Text 90"/>
           <p:cNvSpPr txBox="1"/>
           <p:nvPr/>
         </p:nvSpPr>
@@ -5257,7 +4968,7 @@
       </p:sp>
       <p:sp>
         <p:nvSpPr>
-          <p:cNvPr id="102" name="Shape 100"/>
+          <p:cNvPr id="93" name="Shape 91"/>
           <p:cNvSpPr/>
           <p:nvPr/>
         </p:nvSpPr>
@@ -5282,7 +4993,7 @@
       </p:sp>
       <p:sp>
         <p:nvSpPr>
-          <p:cNvPr id="103" name="Text 101"/>
+          <p:cNvPr id="94" name="Text 92"/>
           <p:cNvSpPr txBox="1"/>
           <p:nvPr/>
         </p:nvSpPr>
@@ -5321,7 +5032,7 @@
       </p:sp>
       <p:sp>
         <p:nvSpPr>
-          <p:cNvPr id="104" name="Shape 102"/>
+          <p:cNvPr id="95" name="Shape 93"/>
           <p:cNvSpPr/>
           <p:nvPr/>
         </p:nvSpPr>
@@ -5348,7 +5059,7 @@
       </p:sp>
       <p:sp>
         <p:nvSpPr>
-          <p:cNvPr id="105" name="Text 103"/>
+          <p:cNvPr id="96" name="Text 94"/>
           <p:cNvSpPr txBox="1"/>
           <p:nvPr/>
         </p:nvSpPr>
@@ -5387,7 +5098,7 @@
       </p:sp>
       <p:sp>
         <p:nvSpPr>
-          <p:cNvPr id="106" name="Text 104"/>
+          <p:cNvPr id="97" name="Text 95"/>
           <p:cNvSpPr txBox="1"/>
           <p:nvPr/>
         </p:nvSpPr>
@@ -5426,7 +5137,7 @@
       </p:sp>
       <p:sp>
         <p:nvSpPr>
-          <p:cNvPr id="107" name="Shape 105"/>
+          <p:cNvPr id="98" name="Shape 96"/>
           <p:cNvSpPr/>
           <p:nvPr/>
         </p:nvSpPr>
@@ -5451,7 +5162,7 @@
       </p:sp>
       <p:sp>
         <p:nvSpPr>
-          <p:cNvPr id="108" name="Shape 106"/>
+          <p:cNvPr id="99" name="Shape 97"/>
           <p:cNvSpPr/>
           <p:nvPr/>
         </p:nvSpPr>
@@ -5476,7 +5187,7 @@
       </p:sp>
       <p:sp>
         <p:nvSpPr>
-          <p:cNvPr id="109" name="Shape 107"/>
+          <p:cNvPr id="100" name="Shape 98"/>
           <p:cNvSpPr/>
           <p:nvPr/>
         </p:nvSpPr>
@@ -5501,7 +5212,7 @@
       </p:sp>
       <p:sp>
         <p:nvSpPr>
-          <p:cNvPr id="110" name="Text 108"/>
+          <p:cNvPr id="101" name="Text 99"/>
           <p:cNvSpPr txBox="1"/>
           <p:nvPr/>
         </p:nvSpPr>

</xml_diff>

<commit_message>
Update management deck for BigQuery and Application Integration
Co-Authored-By: Claude Sonnet 5.5 <noreply@anthropic.com>
Claude-Session: https://claude.ai/code/session_01Aj5vE1JNcAxiTqppU4PS2Y
</commit_message>
<xml_diff>
--- a/docs/Campaign_Provisioner_Management_Deck.pptx
+++ b/docs/Campaign_Provisioner_Management_Deck.pptx
@@ -1125,7 +1125,7 @@
                 <a:ea typeface="Calibri" pitchFamily="34" charset="-122"/>
                 <a:cs typeface="Calibri" pitchFamily="34" charset="-120"/>
               </a:rPr>
-              <a:t>An Autonomous Marketing Logistics Agent for Inventory, Procurement and Budget Approval</a:t>
+              <a:t>Google Next 2027 Edition: An Autonomous Marketing Logistics Agent on BigQuery and Application Integration, with Human-in-the-Loop Approvals</a:t>
             </a:r>
             <a:endParaRPr lang="en-US" sz="2200" dirty="0"/>
           </a:p>
@@ -1278,7 +1278,7 @@
                 <a:ea typeface="Calibri" pitchFamily="34" charset="-122"/>
                 <a:cs typeface="Calibri" pitchFamily="34" charset="-120"/>
               </a:rPr>
-              <a:t>Campaign logistics are slow and fragmented. Teams chase stock levels in one system, vendor quotes in another and budget sign-off by email, so launches slip and spend goes unchecked.</a:t>
+              <a:t>Event campaign logistics are slow and fragmented. Teams chase stock levels in one system, vendor quotes in another and budget sign-off by email, so launches slip and spend goes unchecked.</a:t>
             </a:r>
             <a:endParaRPr lang="en-US" sz="1600" dirty="0"/>
           </a:p>
@@ -1296,7 +1296,7 @@
                 <a:ea typeface="Calibri" pitchFamily="34" charset="-122"/>
                 <a:cs typeface="Calibri" pitchFamily="34" charset="-120"/>
               </a:rPr>
-              <a:t>The agent works as an autonomous logistics coordinator. A central orchestrator registers each campaign request and governs three specialist sub-agents: Inventory checks and reserves stock, Procurement gets vendor quotes and places purchase orders, and Budget validates funds. Spend above the high-value threshold pauses for a human approver, and no purchase order can be placed without an approved budget.</a:t>
+              <a:t>The agent works as an autonomous logistics coordinator. A central orchestrator registers each request and governs three specialist sub-agents: Inventory checks and reserves stock, Procurement gets vendor quotes and creates purchase orders, and Budget validates funds. All data is read from BigQuery, and purchase orders and approver alerts run as Google Application Integration workflows. Spend above the tier limits pauses for a named human approver, and no purchase order can be created without an approved budget.</a:t>
             </a:r>
             <a:endParaRPr lang="en-US" sz="1600" dirty="0"/>
           </a:p>
@@ -1438,7 +1438,7 @@
                 <a:ea typeface="Calibri" pitchFamily="34" charset="-122"/>
                 <a:cs typeface="Calibri" pitchFamily="34" charset="-120"/>
               </a:rPr>
-              <a:t>Checks live stock, reserves available units and calculates shortfalls. Procurement compares vendor quotes on price and lead time and recommends the best fit for the campaign date.</a:t>
+              <a:t>Reads live stock, vendor prices and budgets from BigQuery, reserves available units and calculates shortfalls. Procurement compares vendor quotes on price and lead time and recommends the best fit.</a:t>
             </a:r>
             <a:endParaRPr lang="en-US" sz="1200" dirty="0"/>
           </a:p>
@@ -1539,7 +1539,7 @@
                 <a:ea typeface="Calibri" pitchFamily="34" charset="-122"/>
                 <a:cs typeface="Calibri" pitchFamily="34" charset="-120"/>
               </a:rPr>
-              <a:t>Governed Budget Approval</a:t>
+              <a:t>Tiered Human Approval</a:t>
             </a:r>
             <a:endParaRPr lang="en-US" sz="1800" dirty="0"/>
           </a:p>
@@ -1578,7 +1578,7 @@
                 <a:ea typeface="Calibri" pitchFamily="34" charset="-122"/>
                 <a:cs typeface="Calibri" pitchFamily="34" charset="-120"/>
               </a:rPr>
-              <a:t>Validates the campaign budget and approves routine spend by policy. High-value requests pause for a named human approver with the full justification, and rejected requests stop the workflow.</a:t>
+              <a:t>Approval tiers are stored in BigQuery. Routine spend is approved by policy, while higher tiers notify and pause for a named human approver (Marketing Director, or VP Marketing and Finance Controller).</a:t>
             </a:r>
             <a:endParaRPr lang="en-US" sz="1200" dirty="0"/>
           </a:p>
@@ -1718,7 +1718,7 @@
                 <a:ea typeface="Calibri" pitchFamily="34" charset="-122"/>
                 <a:cs typeface="Calibri" pitchFamily="34" charset="-120"/>
               </a:rPr>
-              <a:t>Purchase orders are hard-blocked until an approved budget covers them. Every action is logged to an audit trail, and the orchestrator returns one consolidated summary of stock, orders and remaining budget.</a:t>
+              <a:t>Purchase orders are created through Application Integration and hard-blocked until an approved budget covers them. Every action is written to a BigQuery audit log, and the orchestrator returns one consolidated summary.</a:t>
             </a:r>
             <a:endParaRPr lang="en-US" sz="1200" dirty="0"/>
           </a:p>
@@ -1949,7 +1949,7 @@
                 <a:ea typeface="Calibri" pitchFamily="34" charset="-122"/>
                 <a:cs typeface="Calibri" pitchFamily="34" charset="-120"/>
               </a:rPr>
-              <a:t>Finance Approver (HITL)</a:t>
+              <a:t>Approver (HITL)</a:t>
             </a:r>
             <a:endParaRPr lang="en-US" sz="900" dirty="0"/>
           </a:p>
@@ -2779,7 +2779,7 @@
                 <a:ea typeface="Calibri" pitchFamily="34" charset="-122"/>
                 <a:cs typeface="Calibri" pitchFamily="34" charset="-120"/>
               </a:rPr>
-              <a:t>Check live stock by SKU</a:t>
+              <a:t>Read stock from BigQuery</a:t>
             </a:r>
             <a:endParaRPr lang="en-US" sz="850" dirty="0"/>
           </a:p>
@@ -2918,7 +2918,7 @@
                 <a:ea typeface="Calibri" pitchFamily="34" charset="-122"/>
                 <a:cs typeface="Calibri" pitchFamily="34" charset="-120"/>
               </a:rPr>
-              <a:t>(Quote &amp; Place PO)</a:t>
+              <a:t>(Quote &amp; Create PO)</a:t>
             </a:r>
             <a:endParaRPr lang="en-US" sz="800" dirty="0"/>
           </a:p>
@@ -2983,7 +2983,7 @@
                 <a:ea typeface="Calibri" pitchFamily="34" charset="-122"/>
                 <a:cs typeface="Calibri" pitchFamily="34" charset="-120"/>
               </a:rPr>
-              <a:t>Fetch vendor quotes</a:t>
+              <a:t>Fetch quotes from BigQuery</a:t>
             </a:r>
             <a:endParaRPr lang="en-US" sz="850" dirty="0"/>
           </a:p>
@@ -3019,7 +3019,7 @@
                 <a:ea typeface="Calibri" pitchFamily="34" charset="-122"/>
                 <a:cs typeface="Calibri" pitchFamily="34" charset="-120"/>
               </a:rPr>
-              <a:t>Place PO only if approved</a:t>
+              <a:t>Create PO via App Integration</a:t>
             </a:r>
             <a:endParaRPr lang="en-US" sz="850" dirty="0"/>
           </a:p>
@@ -3187,7 +3187,7 @@
                 <a:ea typeface="Calibri" pitchFamily="34" charset="-122"/>
                 <a:cs typeface="Calibri" pitchFamily="34" charset="-120"/>
               </a:rPr>
-              <a:t>Check remaining budget</a:t>
+              <a:t>Check budget &amp; approval tier</a:t>
             </a:r>
             <a:endParaRPr lang="en-US" sz="850" dirty="0"/>
           </a:p>
@@ -3205,7 +3205,7 @@
                 <a:ea typeface="Calibri" pitchFamily="34" charset="-122"/>
                 <a:cs typeface="Calibri" pitchFamily="34" charset="-120"/>
               </a:rPr>
-              <a:t>Auto-approve under threshold</a:t>
+              <a:t>Notify approver (workflow)</a:t>
             </a:r>
             <a:endParaRPr lang="en-US" sz="850" dirty="0"/>
           </a:p>
@@ -3223,7 +3223,7 @@
                 <a:ea typeface="Calibri" pitchFamily="34" charset="-122"/>
                 <a:cs typeface="Calibri" pitchFamily="34" charset="-120"/>
               </a:rPr>
-              <a:t>Human approval above threshold</a:t>
+              <a:t>Human approval above tier limit</a:t>
             </a:r>
             <a:endParaRPr lang="en-US" sz="850" dirty="0"/>
           </a:p>
@@ -3378,7 +3378,7 @@
                 <a:ea typeface="Calibri" pitchFamily="34" charset="-122"/>
                 <a:cs typeface="Calibri" pitchFamily="34" charset="-120"/>
               </a:rPr>
-              <a:t>Budget Policy &amp; Thresholds</a:t>
+              <a:t>Approval Policy (BigQuery)</a:t>
             </a:r>
             <a:endParaRPr lang="en-US" sz="800" dirty="0"/>
           </a:p>
@@ -3417,7 +3417,7 @@
                 <a:ea typeface="Calibri" pitchFamily="34" charset="-122"/>
                 <a:cs typeface="Calibri" pitchFamily="34" charset="-120"/>
               </a:rPr>
-              <a:t>High-value limit, approval rules</a:t>
+              <a:t>Tiers, limits, approver roles</a:t>
             </a:r>
             <a:endParaRPr lang="en-US" sz="800" dirty="0"/>
           </a:p>
@@ -3522,7 +3522,7 @@
                 <a:ea typeface="Calibri" pitchFamily="34" charset="-122"/>
                 <a:cs typeface="Calibri" pitchFamily="34" charset="-120"/>
               </a:rPr>
-              <a:t>Request state, approvals, POs</a:t>
+              <a:t>Conversation &amp; pending approvals</a:t>
             </a:r>
             <a:endParaRPr lang="en-US" sz="800" dirty="0"/>
           </a:p>
@@ -3588,7 +3588,7 @@
                 <a:ea typeface="Calibri" pitchFamily="34" charset="-122"/>
                 <a:cs typeface="Calibri" pitchFamily="34" charset="-120"/>
               </a:rPr>
-              <a:t>Audit Trail &amp; Artifact Cache</a:t>
+              <a:t>Audit Log (BigQuery)</a:t>
             </a:r>
             <a:endParaRPr lang="en-US" sz="800" dirty="0"/>
           </a:p>
@@ -3627,7 +3627,7 @@
                 <a:ea typeface="Calibri" pitchFamily="34" charset="-122"/>
                 <a:cs typeface="Calibri" pitchFamily="34" charset="-120"/>
               </a:rPr>
-              <a:t>Actions, quotes, summaries</a:t>
+              <a:t>Every governed action</a:t>
             </a:r>
             <a:endParaRPr lang="en-US" sz="800" dirty="0"/>
           </a:p>
@@ -4387,7 +4387,7 @@
                 <a:ea typeface="Calibri" pitchFamily="34" charset="-122"/>
                 <a:cs typeface="Calibri" pitchFamily="34" charset="-120"/>
               </a:rPr>
-              <a:t>MCP / Tool Calls</a:t>
+              <a:t>ADK Tools / Connectors</a:t>
             </a:r>
             <a:endParaRPr lang="en-US" sz="800" dirty="0"/>
           </a:p>
@@ -4476,7 +4476,7 @@
                 <a:ea typeface="Calibri" pitchFamily="34" charset="-122"/>
                 <a:cs typeface="Calibri" pitchFamily="34" charset="-120"/>
               </a:rPr>
-              <a:t>Enterprise Data Integration</a:t>
+              <a:t>BigQuery (Enterprise Data)</a:t>
             </a:r>
             <a:endParaRPr lang="en-US" sz="900" dirty="0"/>
           </a:p>
@@ -4542,7 +4542,7 @@
                 <a:ea typeface="Calibri" pitchFamily="34" charset="-122"/>
                 <a:cs typeface="Calibri" pitchFamily="34" charset="-120"/>
               </a:rPr>
-              <a:t>ERP / Inventory System</a:t>
+              <a:t>Inventory &amp; Vendors</a:t>
             </a:r>
             <a:endParaRPr lang="en-US" sz="800" dirty="0"/>
           </a:p>
@@ -4581,7 +4581,7 @@
                 <a:ea typeface="Calibri" pitchFamily="34" charset="-122"/>
                 <a:cs typeface="Calibri" pitchFamily="34" charset="-120"/>
               </a:rPr>
-              <a:t>Stock levels, reservations</a:t>
+              <a:t>Stock, reservations, prices</a:t>
             </a:r>
             <a:endParaRPr lang="en-US" sz="800" dirty="0"/>
           </a:p>
@@ -4647,7 +4647,7 @@
                 <a:ea typeface="Calibri" pitchFamily="34" charset="-122"/>
                 <a:cs typeface="Calibri" pitchFamily="34" charset="-120"/>
               </a:rPr>
-              <a:t>Vendor Catalog / Procurement</a:t>
+              <a:t>Budget Ledger &amp; Policy</a:t>
             </a:r>
             <a:endParaRPr lang="en-US" sz="800" dirty="0"/>
           </a:p>
@@ -4686,7 +4686,7 @@
                 <a:ea typeface="Calibri" pitchFamily="34" charset="-122"/>
                 <a:cs typeface="Calibri" pitchFamily="34" charset="-120"/>
               </a:rPr>
-              <a:t>Quotes, purchase orders</a:t>
+              <a:t>Budgets, tiers, audit log</a:t>
             </a:r>
             <a:endParaRPr lang="en-US" sz="800" dirty="0"/>
           </a:p>
@@ -4750,7 +4750,7 @@
                 <a:ea typeface="Calibri" pitchFamily="34" charset="-122"/>
                 <a:cs typeface="Calibri" pitchFamily="34" charset="-120"/>
               </a:rPr>
-              <a:t>Action &amp; Execution Layer</a:t>
+              <a:t>Application Integration</a:t>
             </a:r>
             <a:endParaRPr lang="en-US" sz="900" dirty="0"/>
           </a:p>
@@ -4816,7 +4816,7 @@
                 <a:ea typeface="Calibri" pitchFamily="34" charset="-122"/>
                 <a:cs typeface="Calibri" pitchFamily="34" charset="-120"/>
               </a:rPr>
-              <a:t>Purchase Order API</a:t>
+              <a:t>Create Purchase Order</a:t>
             </a:r>
             <a:endParaRPr lang="en-US" sz="800" dirty="0"/>
           </a:p>
@@ -4855,7 +4855,7 @@
                 <a:ea typeface="Calibri" pitchFamily="34" charset="-122"/>
                 <a:cs typeface="Calibri" pitchFamily="34" charset="-120"/>
               </a:rPr>
-              <a:t>Place and track POs</a:t>
+              <a:t>API trigger: ERP, vendor</a:t>
             </a:r>
             <a:endParaRPr lang="en-US" sz="800" dirty="0"/>
           </a:p>
@@ -4921,7 +4921,7 @@
                 <a:ea typeface="Calibri" pitchFamily="34" charset="-122"/>
                 <a:cs typeface="Calibri" pitchFamily="34" charset="-120"/>
               </a:rPr>
-              <a:t>Approval Workflow</a:t>
+              <a:t>Notify Approver</a:t>
             </a:r>
             <a:endParaRPr lang="en-US" sz="800" dirty="0"/>
           </a:p>
@@ -4960,7 +4960,7 @@
                 <a:ea typeface="Calibri" pitchFamily="34" charset="-122"/>
                 <a:cs typeface="Calibri" pitchFamily="34" charset="-120"/>
               </a:rPr>
-              <a:t>HITL request &amp; decision</a:t>
+              <a:t>API trigger: Chat / email</a:t>
             </a:r>
             <a:endParaRPr lang="en-US" sz="800" dirty="0"/>
           </a:p>

</xml_diff>

<commit_message>
Update README and docs with the verified setup status; deck now names BigQuery and Application Integration explicitly (triggers, tables, email)
Co-Authored-By: Claude Sonnet 5.5 <noreply@anthropic.com>
Claude-Session: https://claude.ai/code/session_01Aj5vE1JNcAxiTqppU4PS2Y
</commit_message>
<xml_diff>
--- a/docs/Campaign_Provisioner_Management_Deck.pptx
+++ b/docs/Campaign_Provisioner_Management_Deck.pptx
@@ -680,7 +680,7 @@
           <a:p>
             <a:r>
               <a:rPr lang="en-US" dirty="0"/>
-              <a:t>Reference architecture. Every element is a native, editable PowerPoint shape or text box - no images.</a:t>
+              <a:t>Reference architecture. Every element is a native, editable PowerPoint shape or text box - no images. Google BigQuery holds all data (inventory, vendor prices, budget ledger, approval policy, approver emails, audit log). Google Application Integration runs the two workflow actions: create_purchase_order and notify_approver (sends the approval email). The human Confirm / Reject happens in the chat; purchase orders are blocked in code without an approved budget.</a:t>
             </a:r>
             <a:endParaRPr lang="en-US" dirty="0"/>
           </a:p>
@@ -1578,7 +1578,7 @@
                 <a:ea typeface="Calibri" pitchFamily="34" charset="-122"/>
                 <a:cs typeface="Calibri" pitchFamily="34" charset="-120"/>
               </a:rPr>
-              <a:t>Approval tiers are stored in BigQuery. Routine spend is approved by policy, while higher tiers notify and pause for a named human approver (Marketing Director, or VP Marketing and Finance Controller).</a:t>
+              <a:t>Approval tiers and approver emails are stored in BigQuery. Routine spend is approved by policy, while higher tiers are emailed to the approver through Application Integration and pause for a named human Confirm (Marketing Director, or VP Marketing and Finance Controller).</a:t>
             </a:r>
             <a:endParaRPr lang="en-US" sz="1200" dirty="0"/>
           </a:p>
@@ -2779,7 +2779,7 @@
                 <a:ea typeface="Calibri" pitchFamily="34" charset="-122"/>
                 <a:cs typeface="Calibri" pitchFamily="34" charset="-120"/>
               </a:rPr>
-              <a:t>Read stock from BigQuery</a:t>
+              <a:t>Read stock (BigQuery)</a:t>
             </a:r>
             <a:endParaRPr lang="en-US" sz="850" dirty="0"/>
           </a:p>
@@ -2797,7 +2797,7 @@
                 <a:ea typeface="Calibri" pitchFamily="34" charset="-122"/>
                 <a:cs typeface="Calibri" pitchFamily="34" charset="-120"/>
               </a:rPr>
-              <a:t>Reserve available units</a:t>
+              <a:t>Reserve units (BigQuery)</a:t>
             </a:r>
             <a:endParaRPr lang="en-US" sz="850" dirty="0"/>
           </a:p>
@@ -2983,7 +2983,7 @@
                 <a:ea typeface="Calibri" pitchFamily="34" charset="-122"/>
                 <a:cs typeface="Calibri" pitchFamily="34" charset="-120"/>
               </a:rPr>
-              <a:t>Fetch quotes from BigQuery</a:t>
+              <a:t>Fetch quotes (BigQuery)</a:t>
             </a:r>
             <a:endParaRPr lang="en-US" sz="850" dirty="0"/>
           </a:p>
@@ -3019,7 +3019,7 @@
                 <a:ea typeface="Calibri" pitchFamily="34" charset="-122"/>
                 <a:cs typeface="Calibri" pitchFamily="34" charset="-120"/>
               </a:rPr>
-              <a:t>Create PO via App Integration</a:t>
+              <a:t>Create PO (App Integration)</a:t>
             </a:r>
             <a:endParaRPr lang="en-US" sz="850" dirty="0"/>
           </a:p>
@@ -3187,7 +3187,7 @@
                 <a:ea typeface="Calibri" pitchFamily="34" charset="-122"/>
                 <a:cs typeface="Calibri" pitchFamily="34" charset="-120"/>
               </a:rPr>
-              <a:t>Check budget &amp; approval tier</a:t>
+              <a:t>Check budget &amp; tier (BigQuery)</a:t>
             </a:r>
             <a:endParaRPr lang="en-US" sz="850" dirty="0"/>
           </a:p>
@@ -3205,7 +3205,7 @@
                 <a:ea typeface="Calibri" pitchFamily="34" charset="-122"/>
                 <a:cs typeface="Calibri" pitchFamily="34" charset="-120"/>
               </a:rPr>
-              <a:t>Notify approver (workflow)</a:t>
+              <a:t>Email approver (App Integration)</a:t>
             </a:r>
             <a:endParaRPr lang="en-US" sz="850" dirty="0"/>
           </a:p>
@@ -3223,7 +3223,7 @@
                 <a:ea typeface="Calibri" pitchFamily="34" charset="-122"/>
                 <a:cs typeface="Calibri" pitchFamily="34" charset="-120"/>
               </a:rPr>
-              <a:t>Human approval above tier limit</a:t>
+              <a:t>Human Confirm / Reject in chat</a:t>
             </a:r>
             <a:endParaRPr lang="en-US" sz="850" dirty="0"/>
           </a:p>
@@ -4387,7 +4387,7 @@
                 <a:ea typeface="Calibri" pitchFamily="34" charset="-122"/>
                 <a:cs typeface="Calibri" pitchFamily="34" charset="-120"/>
               </a:rPr>
-              <a:t>ADK Tools / Connectors</a:t>
+              <a:t>BigQuery API  |  ADK Application Integration toolset</a:t>
             </a:r>
             <a:endParaRPr lang="en-US" sz="800" dirty="0"/>
           </a:p>
@@ -4476,7 +4476,7 @@
                 <a:ea typeface="Calibri" pitchFamily="34" charset="-122"/>
                 <a:cs typeface="Calibri" pitchFamily="34" charset="-120"/>
               </a:rPr>
-              <a:t>BigQuery (Enterprise Data)</a:t>
+              <a:t>Google BigQuery (Data)</a:t>
             </a:r>
             <a:endParaRPr lang="en-US" sz="900" dirty="0"/>
           </a:p>
@@ -4542,7 +4542,7 @@
                 <a:ea typeface="Calibri" pitchFamily="34" charset="-122"/>
                 <a:cs typeface="Calibri" pitchFamily="34" charset="-120"/>
               </a:rPr>
-              <a:t>Inventory &amp; Vendors</a:t>
+              <a:t>Stock, Vendors, Budgets</a:t>
             </a:r>
             <a:endParaRPr lang="en-US" sz="800" dirty="0"/>
           </a:p>
@@ -4581,7 +4581,7 @@
                 <a:ea typeface="Calibri" pitchFamily="34" charset="-122"/>
                 <a:cs typeface="Calibri" pitchFamily="34" charset="-120"/>
               </a:rPr>
-              <a:t>Stock, reservations, prices</a:t>
+              <a:t>Tables + views, read &amp; write</a:t>
             </a:r>
             <a:endParaRPr lang="en-US" sz="800" dirty="0"/>
           </a:p>
@@ -4647,7 +4647,7 @@
                 <a:ea typeface="Calibri" pitchFamily="34" charset="-122"/>
                 <a:cs typeface="Calibri" pitchFamily="34" charset="-120"/>
               </a:rPr>
-              <a:t>Budget Ledger &amp; Policy</a:t>
+              <a:t>Approval Policy &amp; Audit</a:t>
             </a:r>
             <a:endParaRPr lang="en-US" sz="800" dirty="0"/>
           </a:p>
@@ -4686,7 +4686,7 @@
                 <a:ea typeface="Calibri" pitchFamily="34" charset="-122"/>
                 <a:cs typeface="Calibri" pitchFamily="34" charset="-120"/>
               </a:rPr>
-              <a:t>Budgets, tiers, audit log</a:t>
+              <a:t>Tiers, approver emails, log</a:t>
             </a:r>
             <a:endParaRPr lang="en-US" sz="800" dirty="0"/>
           </a:p>
@@ -4816,7 +4816,7 @@
                 <a:ea typeface="Calibri" pitchFamily="34" charset="-122"/>
                 <a:cs typeface="Calibri" pitchFamily="34" charset="-120"/>
               </a:rPr>
-              <a:t>Create Purchase Order</a:t>
+              <a:t>create_purchase_order</a:t>
             </a:r>
             <a:endParaRPr lang="en-US" sz="800" dirty="0"/>
           </a:p>
@@ -4855,7 +4855,7 @@
                 <a:ea typeface="Calibri" pitchFamily="34" charset="-122"/>
                 <a:cs typeface="Calibri" pitchFamily="34" charset="-120"/>
               </a:rPr>
-              <a:t>API trigger: ERP, vendor</a:t>
+              <a:t>API trigger: creates the PO</a:t>
             </a:r>
             <a:endParaRPr lang="en-US" sz="800" dirty="0"/>
           </a:p>
@@ -4921,7 +4921,7 @@
                 <a:ea typeface="Calibri" pitchFamily="34" charset="-122"/>
                 <a:cs typeface="Calibri" pitchFamily="34" charset="-120"/>
               </a:rPr>
-              <a:t>Notify Approver</a:t>
+              <a:t>notify_approver</a:t>
             </a:r>
             <a:endParaRPr lang="en-US" sz="800" dirty="0"/>
           </a:p>
@@ -4960,7 +4960,7 @@
                 <a:ea typeface="Calibri" pitchFamily="34" charset="-122"/>
                 <a:cs typeface="Calibri" pitchFamily="34" charset="-120"/>
               </a:rPr>
-              <a:t>API trigger: Chat / email</a:t>
+              <a:t>API trigger: emails approver</a:t>
             </a:r>
             <a:endParaRPr lang="en-US" sz="800" dirty="0"/>
           </a:p>

</xml_diff>

<commit_message>
Add Agent Engine deployment as the final step: deploy script, client with human approval handling, docs section 14, deck label
Co-Authored-By: Claude Sonnet 5.5 <noreply@anthropic.com>
Claude-Session: https://claude.ai/code/session_01Aj5vE1JNcAxiTqppU4PS2Y
</commit_message>
<xml_diff>
--- a/docs/Campaign_Provisioner_Management_Deck.pptx
+++ b/docs/Campaign_Provisioner_Management_Deck.pptx
@@ -680,7 +680,7 @@
           <a:p>
             <a:r>
               <a:rPr lang="en-US" dirty="0"/>
-              <a:t>Reference architecture. Every element is a native, editable PowerPoint shape or text box - no images. Google BigQuery holds all data (inventory, vendor prices, budget ledger, approval policy, approver emails, audit log). Google Application Integration runs the two workflow actions: create_purchase_order and notify_approver (sends the approval email). The human Confirm / Reject happens in the chat; purchase orders are blocked in code without an approved budget.</a:t>
+              <a:t>Reference architecture. Every element is a native, editable PowerPoint shape or text box - no images. Google BigQuery holds all data (inventory, vendor prices, budget ledger, approval policy, approver emails, audit log). Google Application Integration runs the two workflow actions: create_purchase_order and notify_approver (sends the approval email). The agent is deployed to Vertex AI Agent Engine (hosted runtime and managed sessions). The human Confirm / Reject is returned to the client (chat UI or Gemini Enterprise); purchase orders are blocked in code without an approved budget.</a:t>
             </a:r>
             <a:endParaRPr lang="en-US" dirty="0"/>
           </a:p>
@@ -2310,7 +2310,7 @@
                 <a:ea typeface="Calibri" pitchFamily="34" charset="-122"/>
                 <a:cs typeface="Calibri" pitchFamily="34" charset="-120"/>
               </a:rPr>
-              <a:t>Google Cloud ( Agent Runtime )</a:t>
+              <a:t>Google Cloud ( Vertex AI Agent Engine runtime )</a:t>
             </a:r>
             <a:endParaRPr lang="en-US" sz="1000" dirty="0"/>
           </a:p>
@@ -3483,7 +3483,7 @@
                 <a:ea typeface="Calibri" pitchFamily="34" charset="-122"/>
                 <a:cs typeface="Calibri" pitchFamily="34" charset="-120"/>
               </a:rPr>
-              <a:t>Session Working Memory</a:t>
+              <a:t>Agent Engine Sessions</a:t>
             </a:r>
             <a:endParaRPr lang="en-US" sz="800" dirty="0"/>
           </a:p>
@@ -3522,7 +3522,7 @@
                 <a:ea typeface="Calibri" pitchFamily="34" charset="-122"/>
                 <a:cs typeface="Calibri" pitchFamily="34" charset="-120"/>
               </a:rPr>
-              <a:t>Conversation &amp; pending approvals</a:t>
+              <a:t>Chat state &amp; pending approvals</a:t>
             </a:r>
             <a:endParaRPr lang="en-US" sz="800" dirty="0"/>
           </a:p>

</xml_diff>

<commit_message>
Fix flow stopping after the human approval: the orchestrator now holds approve_budget (resume continues in the same agent); budget agent validates and notifies only. Add end-to-end test with a scripted model through ADK's runner. Deck and docs updated.
Co-Authored-By: Claude Sonnet 5.5 <noreply@anthropic.com>
Claude-Session: https://claude.ai/code/session_01Aj5vE1JNcAxiTqppU4PS2Y
</commit_message>
<xml_diff>
--- a/docs/Campaign_Provisioner_Management_Deck.pptx
+++ b/docs/Campaign_Provisioner_Management_Deck.pptx
@@ -2520,7 +2520,7 @@
                 <a:ea typeface="Calibri" pitchFamily="34" charset="-122"/>
                 <a:cs typeface="Calibri" pitchFamily="34" charset="-120"/>
               </a:rPr>
-              <a:t>Greeting &amp; Intent  •  Multi-Agent Coordination  •  State Coordination  •  Human Approval Gate  •  Result Aggregation</a:t>
+              <a:t>Greeting &amp; Intent  •  Multi-Agent Coordination  •  State Coordination  •  Human Approval Gate (Confirm / Reject)  •  Result Aggregation</a:t>
             </a:r>
             <a:endParaRPr lang="en-US" sz="850" dirty="0"/>
           </a:p>
@@ -3122,7 +3122,7 @@
                 <a:ea typeface="Calibri" pitchFamily="34" charset="-122"/>
                 <a:cs typeface="Calibri" pitchFamily="34" charset="-120"/>
               </a:rPr>
-              <a:t>(Validate &amp; Approve - HITL)</a:t>
+              <a:t>(Validate &amp; Notify)</a:t>
             </a:r>
             <a:endParaRPr lang="en-US" sz="800" dirty="0"/>
           </a:p>
@@ -3223,7 +3223,7 @@
                 <a:ea typeface="Calibri" pitchFamily="34" charset="-122"/>
                 <a:cs typeface="Calibri" pitchFamily="34" charset="-120"/>
               </a:rPr>
-              <a:t>Human Confirm / Reject in chat</a:t>
+              <a:t>Report back (never approves)</a:t>
             </a:r>
             <a:endParaRPr lang="en-US" sz="850" dirty="0"/>
           </a:p>

</xml_diff>

<commit_message>
Docs and deck for emailed approval links and the configurable service account
Co-Authored-By: Claude Sonnet 5.5 <noreply@anthropic.com>
Claude-Session: https://claude.ai/code/session_01Aj5vE1JNcAxiTqppU4PS2Y
</commit_message>
<xml_diff>
--- a/docs/Campaign_Provisioner_Management_Deck.pptx
+++ b/docs/Campaign_Provisioner_Management_Deck.pptx
@@ -680,7 +680,7 @@
           <a:p>
             <a:r>
               <a:rPr lang="en-US" dirty="0"/>
-              <a:t>Reference architecture. Every element is a native, editable PowerPoint shape or text box - no images. Google BigQuery holds all data (inventory, vendor prices, budget ledger, approval policy, approver emails, audit log). Google Application Integration runs the two workflow actions: create_purchase_order and notify_approver (sends the approval email). The agent is deployed to Vertex AI Agent Engine (hosted runtime and managed sessions). The human Confirm / Reject is returned to the client (chat UI or Gemini Enterprise); purchase orders are blocked in code without an approved budget.</a:t>
+              <a:t>Reference architecture. Every element is a native, editable PowerPoint shape or text box - no images. Google BigQuery holds all data (inventory, vendor prices, budget ledger, approval policy, approver emails, audit log). Google Application Integration runs the two workflow actions: create_purchase_order and notify_approver (sends the approval email). The agent is deployed to Vertex AI Agent Engine (hosted runtime and managed sessions). The human approval is an emailed Approve / Reject link handled by a small Cloud Run service (signed link, no login), which then triggers the order; purchase orders are blocked in code without an approved budget.</a:t>
             </a:r>
             <a:endParaRPr lang="en-US" dirty="0"/>
           </a:p>
@@ -1578,7 +1578,7 @@
                 <a:ea typeface="Calibri" pitchFamily="34" charset="-122"/>
                 <a:cs typeface="Calibri" pitchFamily="34" charset="-120"/>
               </a:rPr>
-              <a:t>Approval tiers and approver emails are stored in BigQuery. Routine spend is approved by policy, while higher tiers are emailed to the approver through Application Integration and pause for a named human Confirm (Marketing Director, or VP Marketing and Finance Controller).</a:t>
+              <a:t>Approval tiers and approver emails are stored in BigQuery. Routine spend is approved by policy. Higher tiers email the approver an Approve / Reject link (no login needed); the click triggers the order (Marketing Director, or VP Marketing and Finance Controller).</a:t>
             </a:r>
             <a:endParaRPr lang="en-US" sz="1200" dirty="0"/>
           </a:p>
@@ -1932,24 +1932,7 @@
                 <a:ea typeface="Calibri" pitchFamily="34" charset="-122"/>
                 <a:cs typeface="Calibri" pitchFamily="34" charset="-120"/>
               </a:rPr>
-              <a:t>Campaign Planner,</a:t>
-            </a:r>
-            <a:endParaRPr lang="en-US" sz="900" dirty="0"/>
-          </a:p>
-          <a:p>
-            <a:pPr algn="ctr" indent="0" marL="0">
-              <a:buNone/>
-            </a:pPr>
-            <a:r>
-              <a:rPr lang="en-US" sz="900" b="1" dirty="0">
-                <a:solidFill>
-                  <a:srgbClr val="1E293B"/>
-                </a:solidFill>
-                <a:latin typeface="Calibri" pitchFamily="34" charset="0"/>
-                <a:ea typeface="Calibri" pitchFamily="34" charset="-122"/>
-                <a:cs typeface="Calibri" pitchFamily="34" charset="-120"/>
-              </a:rPr>
-              <a:t>Approver (HITL)</a:t>
+              <a:t>Campaign Planner</a:t>
             </a:r>
             <a:endParaRPr lang="en-US" sz="900" dirty="0"/>
           </a:p>
@@ -2260,6 +2243,265 @@
         </p:nvSpPr>
         <p:spPr>
           <a:xfrm>
+            <a:off x="365760" y="4572000"/>
+            <a:ext cx="1828800" cy="1234440"/>
+          </a:xfrm>
+          <a:prstGeom prst="rect">
+            <a:avLst/>
+          </a:prstGeom>
+          <a:solidFill>
+            <a:srgbClr val="EFF4FF"/>
+          </a:solidFill>
+          <a:ln w="12700">
+            <a:solidFill>
+              <a:srgbClr val="93A8D8"/>
+            </a:solidFill>
+            <a:prstDash val="solid"/>
+          </a:ln>
+        </p:spPr>
+      </p:sp>
+      <p:sp>
+        <p:nvSpPr>
+          <p:cNvPr id="17" name="Text 15"/>
+          <p:cNvSpPr txBox="1"/>
+          <p:nvPr/>
+        </p:nvSpPr>
+        <p:spPr>
+          <a:xfrm>
+            <a:off x="411480" y="4599432"/>
+            <a:ext cx="1737360" cy="256032"/>
+          </a:xfrm>
+          <a:prstGeom prst="rect">
+            <a:avLst/>
+          </a:prstGeom>
+          <a:noFill/>
+          <a:ln/>
+        </p:spPr>
+        <p:txBody>
+          <a:bodyPr wrap="square" lIns="25400" tIns="25400" rIns="25400" bIns="25400" rtlCol="0" anchor="ctr"/>
+          <a:lstStyle/>
+          <a:p>
+            <a:pPr algn="ctr" indent="0" marL="0">
+              <a:buNone/>
+            </a:pPr>
+            <a:r>
+              <a:rPr lang="en-US" sz="1000" b="1" dirty="0">
+                <a:solidFill>
+                  <a:srgbClr val="1F3A8A"/>
+                </a:solidFill>
+                <a:latin typeface="Calibri" pitchFamily="34" charset="0"/>
+                <a:ea typeface="Calibri" pitchFamily="34" charset="-122"/>
+                <a:cs typeface="Calibri" pitchFamily="34" charset="-120"/>
+              </a:rPr>
+              <a:t>Approver (HITL)</a:t>
+            </a:r>
+            <a:endParaRPr lang="en-US" sz="1000" dirty="0"/>
+          </a:p>
+        </p:txBody>
+      </p:sp>
+      <p:sp>
+        <p:nvSpPr>
+          <p:cNvPr id="18" name="Shape 16"/>
+          <p:cNvSpPr/>
+          <p:nvPr/>
+        </p:nvSpPr>
+        <p:spPr>
+          <a:xfrm>
+            <a:off x="502920" y="4864608"/>
+            <a:ext cx="1554480" cy="384048"/>
+          </a:xfrm>
+          <a:prstGeom prst="roundRect">
+            <a:avLst>
+              <a:gd name="adj" fmla="val 14286"/>
+            </a:avLst>
+          </a:prstGeom>
+          <a:solidFill>
+            <a:srgbClr val="FFFFFF"/>
+          </a:solidFill>
+          <a:ln w="12700">
+            <a:solidFill>
+              <a:srgbClr val="93A8D8"/>
+            </a:solidFill>
+            <a:prstDash val="solid"/>
+          </a:ln>
+        </p:spPr>
+      </p:sp>
+      <p:sp>
+        <p:nvSpPr>
+          <p:cNvPr id="19" name="Text 17"/>
+          <p:cNvSpPr txBox="1"/>
+          <p:nvPr/>
+        </p:nvSpPr>
+        <p:spPr>
+          <a:xfrm>
+            <a:off x="548640" y="4901184"/>
+            <a:ext cx="1463040" cy="310896"/>
+          </a:xfrm>
+          <a:prstGeom prst="rect">
+            <a:avLst/>
+          </a:prstGeom>
+          <a:noFill/>
+          <a:ln/>
+        </p:spPr>
+        <p:txBody>
+          <a:bodyPr wrap="square" lIns="25400" tIns="25400" rIns="25400" bIns="25400" rtlCol="0" anchor="ctr"/>
+          <a:lstStyle/>
+          <a:p>
+            <a:pPr algn="ctr" indent="0" marL="0">
+              <a:buNone/>
+            </a:pPr>
+            <a:r>
+              <a:rPr lang="en-US" sz="800" b="1" dirty="0">
+                <a:solidFill>
+                  <a:srgbClr val="1E293B"/>
+                </a:solidFill>
+                <a:latin typeface="Calibri" pitchFamily="34" charset="0"/>
+                <a:ea typeface="Calibri" pitchFamily="34" charset="-122"/>
+                <a:cs typeface="Calibri" pitchFamily="34" charset="-120"/>
+              </a:rPr>
+              <a:t>Email: Approve / Reject link</a:t>
+            </a:r>
+            <a:endParaRPr lang="en-US" sz="800" dirty="0"/>
+          </a:p>
+        </p:txBody>
+      </p:sp>
+      <p:sp>
+        <p:nvSpPr>
+          <p:cNvPr id="20" name="Shape 18"/>
+          <p:cNvSpPr/>
+          <p:nvPr/>
+        </p:nvSpPr>
+        <p:spPr>
+          <a:xfrm>
+            <a:off x="502920" y="5303520"/>
+            <a:ext cx="1554480" cy="411480"/>
+          </a:xfrm>
+          <a:prstGeom prst="roundRect">
+            <a:avLst>
+              <a:gd name="adj" fmla="val 13333"/>
+            </a:avLst>
+          </a:prstGeom>
+          <a:solidFill>
+            <a:srgbClr val="FFFFFF"/>
+          </a:solidFill>
+          <a:ln w="12700">
+            <a:solidFill>
+              <a:srgbClr val="93A8D8"/>
+            </a:solidFill>
+            <a:prstDash val="solid"/>
+          </a:ln>
+        </p:spPr>
+      </p:sp>
+      <p:sp>
+        <p:nvSpPr>
+          <p:cNvPr id="21" name="Text 19"/>
+          <p:cNvSpPr txBox="1"/>
+          <p:nvPr/>
+        </p:nvSpPr>
+        <p:spPr>
+          <a:xfrm>
+            <a:off x="548640" y="5340096"/>
+            <a:ext cx="1463040" cy="205740"/>
+          </a:xfrm>
+          <a:prstGeom prst="rect">
+            <a:avLst/>
+          </a:prstGeom>
+          <a:noFill/>
+          <a:ln/>
+        </p:spPr>
+        <p:txBody>
+          <a:bodyPr wrap="square" lIns="25400" tIns="25400" rIns="25400" bIns="25400" rtlCol="0" anchor="ctr"/>
+          <a:lstStyle/>
+          <a:p>
+            <a:pPr algn="ctr" indent="0" marL="0">
+              <a:buNone/>
+            </a:pPr>
+            <a:r>
+              <a:rPr lang="en-US" sz="800" b="1" dirty="0">
+                <a:solidFill>
+                  <a:srgbClr val="1E293B"/>
+                </a:solidFill>
+                <a:latin typeface="Calibri" pitchFamily="34" charset="0"/>
+                <a:ea typeface="Calibri" pitchFamily="34" charset="-122"/>
+                <a:cs typeface="Calibri" pitchFamily="34" charset="-120"/>
+              </a:rPr>
+              <a:t>Approval Link Service</a:t>
+            </a:r>
+            <a:endParaRPr lang="en-US" sz="800" dirty="0"/>
+          </a:p>
+        </p:txBody>
+      </p:sp>
+      <p:sp>
+        <p:nvSpPr>
+          <p:cNvPr id="22" name="Text 20"/>
+          <p:cNvSpPr txBox="1"/>
+          <p:nvPr/>
+        </p:nvSpPr>
+        <p:spPr>
+          <a:xfrm>
+            <a:off x="548640" y="5509260"/>
+            <a:ext cx="1463040" cy="185166"/>
+          </a:xfrm>
+          <a:prstGeom prst="rect">
+            <a:avLst/>
+          </a:prstGeom>
+          <a:noFill/>
+          <a:ln/>
+        </p:spPr>
+        <p:txBody>
+          <a:bodyPr wrap="square" lIns="25400" tIns="25400" rIns="25400" bIns="25400" rtlCol="0" anchor="t"/>
+          <a:lstStyle/>
+          <a:p>
+            <a:pPr algn="ctr" indent="0" marL="0">
+              <a:buNone/>
+            </a:pPr>
+            <a:r>
+              <a:rPr lang="en-US" sz="800" dirty="0">
+                <a:solidFill>
+                  <a:srgbClr val="64748B"/>
+                </a:solidFill>
+                <a:latin typeface="Calibri" pitchFamily="34" charset="0"/>
+                <a:ea typeface="Calibri" pitchFamily="34" charset="-122"/>
+                <a:cs typeface="Calibri" pitchFamily="34" charset="-120"/>
+              </a:rPr>
+              <a:t>Cloud Run, no login</a:t>
+            </a:r>
+            <a:endParaRPr lang="en-US" sz="800" dirty="0"/>
+          </a:p>
+        </p:txBody>
+      </p:sp>
+      <p:sp>
+        <p:nvSpPr>
+          <p:cNvPr id="23" name="Shape 21"/>
+          <p:cNvSpPr/>
+          <p:nvPr/>
+        </p:nvSpPr>
+        <p:spPr>
+          <a:xfrm>
+            <a:off x="2194560" y="5440680"/>
+            <a:ext cx="502920" cy="0"/>
+          </a:xfrm>
+          <a:prstGeom prst="line">
+            <a:avLst/>
+          </a:prstGeom>
+          <a:noFill/>
+          <a:ln w="19050">
+            <a:solidFill>
+              <a:srgbClr val="2563EB"/>
+            </a:solidFill>
+            <a:prstDash val="solid"/>
+            <a:tailEnd type="triangle"/>
+          </a:ln>
+        </p:spPr>
+      </p:sp>
+      <p:sp>
+        <p:nvSpPr>
+          <p:cNvPr id="24" name="Shape 22"/>
+          <p:cNvSpPr/>
+          <p:nvPr/>
+        </p:nvSpPr>
+        <p:spPr>
+          <a:xfrm>
             <a:off x="2697480" y="960120"/>
             <a:ext cx="6766560" cy="5074920"/>
           </a:xfrm>
@@ -2279,7 +2521,7 @@
       </p:sp>
       <p:sp>
         <p:nvSpPr>
-          <p:cNvPr id="17" name="Text 15"/>
+          <p:cNvPr id="25" name="Text 23"/>
           <p:cNvSpPr txBox="1"/>
           <p:nvPr/>
         </p:nvSpPr>
@@ -2318,7 +2560,7 @@
       </p:sp>
       <p:sp>
         <p:nvSpPr>
-          <p:cNvPr id="18" name="Shape 16"/>
+          <p:cNvPr id="26" name="Shape 24"/>
           <p:cNvSpPr/>
           <p:nvPr/>
         </p:nvSpPr>
@@ -2343,7 +2585,7 @@
       </p:sp>
       <p:sp>
         <p:nvSpPr>
-          <p:cNvPr id="19" name="Shape 17"/>
+          <p:cNvPr id="27" name="Shape 25"/>
           <p:cNvSpPr/>
           <p:nvPr/>
         </p:nvSpPr>
@@ -2370,7 +2612,7 @@
       </p:sp>
       <p:sp>
         <p:nvSpPr>
-          <p:cNvPr id="20" name="Text 18"/>
+          <p:cNvPr id="28" name="Text 26"/>
           <p:cNvSpPr txBox="1"/>
           <p:nvPr/>
         </p:nvSpPr>
@@ -2409,7 +2651,7 @@
       </p:sp>
       <p:sp>
         <p:nvSpPr>
-          <p:cNvPr id="21" name="Text 19"/>
+          <p:cNvPr id="29" name="Text 27"/>
           <p:cNvSpPr txBox="1"/>
           <p:nvPr/>
         </p:nvSpPr>
@@ -2448,7 +2690,7 @@
       </p:sp>
       <p:sp>
         <p:nvSpPr>
-          <p:cNvPr id="22" name="Shape 20"/>
+          <p:cNvPr id="30" name="Shape 28"/>
           <p:cNvSpPr/>
           <p:nvPr/>
         </p:nvSpPr>
@@ -2475,7 +2717,7 @@
       </p:sp>
       <p:sp>
         <p:nvSpPr>
-          <p:cNvPr id="23" name="Text 21"/>
+          <p:cNvPr id="31" name="Text 29"/>
           <p:cNvSpPr txBox="1"/>
           <p:nvPr/>
         </p:nvSpPr>
@@ -2520,7 +2762,7 @@
                 <a:ea typeface="Calibri" pitchFamily="34" charset="-122"/>
                 <a:cs typeface="Calibri" pitchFamily="34" charset="-120"/>
               </a:rPr>
-              <a:t>Greeting &amp; Intent  •  Multi-Agent Coordination  •  State Coordination  •  Human Approval Gate (Confirm / Reject)  •  Result Aggregation</a:t>
+              <a:t>Greeting &amp; Intent  •  Multi-Agent Coordination  •  State Coordination  •  Human Approval Gate (email link)  •  Result Aggregation</a:t>
             </a:r>
             <a:endParaRPr lang="en-US" sz="850" dirty="0"/>
           </a:p>
@@ -2528,7 +2770,7 @@
       </p:sp>
       <p:sp>
         <p:nvSpPr>
-          <p:cNvPr id="24" name="Shape 22"/>
+          <p:cNvPr id="32" name="Shape 30"/>
           <p:cNvSpPr/>
           <p:nvPr/>
         </p:nvSpPr>
@@ -2553,7 +2795,7 @@
       </p:sp>
       <p:sp>
         <p:nvSpPr>
-          <p:cNvPr id="25" name="Shape 23"/>
+          <p:cNvPr id="33" name="Shape 31"/>
           <p:cNvSpPr/>
           <p:nvPr/>
         </p:nvSpPr>
@@ -2580,7 +2822,7 @@
       </p:sp>
       <p:sp>
         <p:nvSpPr>
-          <p:cNvPr id="26" name="Text 24"/>
+          <p:cNvPr id="34" name="Text 32"/>
           <p:cNvSpPr txBox="1"/>
           <p:nvPr/>
         </p:nvSpPr>
@@ -2619,7 +2861,7 @@
       </p:sp>
       <p:sp>
         <p:nvSpPr>
-          <p:cNvPr id="27" name="Shape 25"/>
+          <p:cNvPr id="35" name="Shape 33"/>
           <p:cNvSpPr/>
           <p:nvPr/>
         </p:nvSpPr>
@@ -2644,7 +2886,7 @@
       </p:sp>
       <p:sp>
         <p:nvSpPr>
-          <p:cNvPr id="28" name="Text 26"/>
+          <p:cNvPr id="36" name="Text 34"/>
           <p:cNvSpPr txBox="1"/>
           <p:nvPr/>
         </p:nvSpPr>
@@ -2683,7 +2925,7 @@
       </p:sp>
       <p:sp>
         <p:nvSpPr>
-          <p:cNvPr id="29" name="Text 27"/>
+          <p:cNvPr id="37" name="Text 35"/>
           <p:cNvSpPr txBox="1"/>
           <p:nvPr/>
         </p:nvSpPr>
@@ -2722,7 +2964,7 @@
       </p:sp>
       <p:sp>
         <p:nvSpPr>
-          <p:cNvPr id="30" name="Shape 28"/>
+          <p:cNvPr id="38" name="Shape 36"/>
           <p:cNvSpPr/>
           <p:nvPr/>
         </p:nvSpPr>
@@ -2747,7 +2989,7 @@
       </p:sp>
       <p:sp>
         <p:nvSpPr>
-          <p:cNvPr id="31" name="Text 29"/>
+          <p:cNvPr id="39" name="Text 37"/>
           <p:cNvSpPr txBox="1"/>
           <p:nvPr/>
         </p:nvSpPr>
@@ -2823,7 +3065,7 @@
       </p:sp>
       <p:sp>
         <p:nvSpPr>
-          <p:cNvPr id="32" name="Shape 30"/>
+          <p:cNvPr id="40" name="Shape 38"/>
           <p:cNvSpPr/>
           <p:nvPr/>
         </p:nvSpPr>
@@ -2848,7 +3090,7 @@
       </p:sp>
       <p:sp>
         <p:nvSpPr>
-          <p:cNvPr id="33" name="Text 31"/>
+          <p:cNvPr id="41" name="Text 39"/>
           <p:cNvSpPr txBox="1"/>
           <p:nvPr/>
         </p:nvSpPr>
@@ -2887,7 +3129,7 @@
       </p:sp>
       <p:sp>
         <p:nvSpPr>
-          <p:cNvPr id="34" name="Text 32"/>
+          <p:cNvPr id="42" name="Text 40"/>
           <p:cNvSpPr txBox="1"/>
           <p:nvPr/>
         </p:nvSpPr>
@@ -2926,7 +3168,7 @@
       </p:sp>
       <p:sp>
         <p:nvSpPr>
-          <p:cNvPr id="35" name="Shape 33"/>
+          <p:cNvPr id="43" name="Shape 41"/>
           <p:cNvSpPr/>
           <p:nvPr/>
         </p:nvSpPr>
@@ -2951,7 +3193,7 @@
       </p:sp>
       <p:sp>
         <p:nvSpPr>
-          <p:cNvPr id="36" name="Text 34"/>
+          <p:cNvPr id="44" name="Text 42"/>
           <p:cNvSpPr txBox="1"/>
           <p:nvPr/>
         </p:nvSpPr>
@@ -3027,7 +3269,7 @@
       </p:sp>
       <p:sp>
         <p:nvSpPr>
-          <p:cNvPr id="37" name="Shape 35"/>
+          <p:cNvPr id="45" name="Shape 43"/>
           <p:cNvSpPr/>
           <p:nvPr/>
         </p:nvSpPr>
@@ -3052,7 +3294,7 @@
       </p:sp>
       <p:sp>
         <p:nvSpPr>
-          <p:cNvPr id="38" name="Text 36"/>
+          <p:cNvPr id="46" name="Text 44"/>
           <p:cNvSpPr txBox="1"/>
           <p:nvPr/>
         </p:nvSpPr>
@@ -3091,7 +3333,7 @@
       </p:sp>
       <p:sp>
         <p:nvSpPr>
-          <p:cNvPr id="39" name="Text 37"/>
+          <p:cNvPr id="47" name="Text 45"/>
           <p:cNvSpPr txBox="1"/>
           <p:nvPr/>
         </p:nvSpPr>
@@ -3130,7 +3372,7 @@
       </p:sp>
       <p:sp>
         <p:nvSpPr>
-          <p:cNvPr id="40" name="Shape 38"/>
+          <p:cNvPr id="48" name="Shape 46"/>
           <p:cNvSpPr/>
           <p:nvPr/>
         </p:nvSpPr>
@@ -3155,7 +3397,7 @@
       </p:sp>
       <p:sp>
         <p:nvSpPr>
-          <p:cNvPr id="41" name="Text 39"/>
+          <p:cNvPr id="49" name="Text 47"/>
           <p:cNvSpPr txBox="1"/>
           <p:nvPr/>
         </p:nvSpPr>
@@ -3205,7 +3447,7 @@
                 <a:ea typeface="Calibri" pitchFamily="34" charset="-122"/>
                 <a:cs typeface="Calibri" pitchFamily="34" charset="-120"/>
               </a:rPr>
-              <a:t>Email approver (App Integration)</a:t>
+              <a:t>Report back (never approves)</a:t>
             </a:r>
             <a:endParaRPr lang="en-US" sz="850" dirty="0"/>
           </a:p>
@@ -3223,7 +3465,7 @@
                 <a:ea typeface="Calibri" pitchFamily="34" charset="-122"/>
                 <a:cs typeface="Calibri" pitchFamily="34" charset="-120"/>
               </a:rPr>
-              <a:t>Report back (never approves)</a:t>
+              <a:t>Approver emailed a link by the Orchestrator</a:t>
             </a:r>
             <a:endParaRPr lang="en-US" sz="850" dirty="0"/>
           </a:p>
@@ -3231,7 +3473,7 @@
       </p:sp>
       <p:sp>
         <p:nvSpPr>
-          <p:cNvPr id="42" name="Shape 40"/>
+          <p:cNvPr id="50" name="Shape 48"/>
           <p:cNvSpPr/>
           <p:nvPr/>
         </p:nvSpPr>
@@ -3256,7 +3498,7 @@
       </p:sp>
       <p:sp>
         <p:nvSpPr>
-          <p:cNvPr id="43" name="Shape 41"/>
+          <p:cNvPr id="51" name="Shape 49"/>
           <p:cNvSpPr/>
           <p:nvPr/>
         </p:nvSpPr>
@@ -3281,7 +3523,7 @@
       </p:sp>
       <p:sp>
         <p:nvSpPr>
-          <p:cNvPr id="44" name="Text 42"/>
+          <p:cNvPr id="52" name="Text 50"/>
           <p:cNvSpPr txBox="1"/>
           <p:nvPr/>
         </p:nvSpPr>
@@ -3320,7 +3562,7 @@
       </p:sp>
       <p:sp>
         <p:nvSpPr>
-          <p:cNvPr id="45" name="Shape 43"/>
+          <p:cNvPr id="53" name="Shape 51"/>
           <p:cNvSpPr/>
           <p:nvPr/>
         </p:nvSpPr>
@@ -3347,7 +3589,7 @@
       </p:sp>
       <p:sp>
         <p:nvSpPr>
-          <p:cNvPr id="46" name="Text 44"/>
+          <p:cNvPr id="54" name="Text 52"/>
           <p:cNvSpPr txBox="1"/>
           <p:nvPr/>
         </p:nvSpPr>
@@ -3386,7 +3628,7 @@
       </p:sp>
       <p:sp>
         <p:nvSpPr>
-          <p:cNvPr id="47" name="Text 45"/>
+          <p:cNvPr id="55" name="Text 53"/>
           <p:cNvSpPr txBox="1"/>
           <p:nvPr/>
         </p:nvSpPr>
@@ -3425,7 +3667,7 @@
       </p:sp>
       <p:sp>
         <p:nvSpPr>
-          <p:cNvPr id="48" name="Shape 46"/>
+          <p:cNvPr id="56" name="Shape 54"/>
           <p:cNvSpPr/>
           <p:nvPr/>
         </p:nvSpPr>
@@ -3452,7 +3694,7 @@
       </p:sp>
       <p:sp>
         <p:nvSpPr>
-          <p:cNvPr id="49" name="Text 47"/>
+          <p:cNvPr id="57" name="Text 55"/>
           <p:cNvSpPr txBox="1"/>
           <p:nvPr/>
         </p:nvSpPr>
@@ -3491,7 +3733,7 @@
       </p:sp>
       <p:sp>
         <p:nvSpPr>
-          <p:cNvPr id="50" name="Text 48"/>
+          <p:cNvPr id="58" name="Text 56"/>
           <p:cNvSpPr txBox="1"/>
           <p:nvPr/>
         </p:nvSpPr>
@@ -3530,7 +3772,7 @@
       </p:sp>
       <p:sp>
         <p:nvSpPr>
-          <p:cNvPr id="51" name="Shape 49"/>
+          <p:cNvPr id="59" name="Shape 57"/>
           <p:cNvSpPr/>
           <p:nvPr/>
         </p:nvSpPr>
@@ -3557,7 +3799,7 @@
       </p:sp>
       <p:sp>
         <p:nvSpPr>
-          <p:cNvPr id="52" name="Text 50"/>
+          <p:cNvPr id="60" name="Text 58"/>
           <p:cNvSpPr txBox="1"/>
           <p:nvPr/>
         </p:nvSpPr>
@@ -3596,7 +3838,7 @@
       </p:sp>
       <p:sp>
         <p:nvSpPr>
-          <p:cNvPr id="53" name="Text 51"/>
+          <p:cNvPr id="61" name="Text 59"/>
           <p:cNvSpPr txBox="1"/>
           <p:nvPr/>
         </p:nvSpPr>
@@ -3635,7 +3877,7 @@
       </p:sp>
       <p:sp>
         <p:nvSpPr>
-          <p:cNvPr id="54" name="Shape 52"/>
+          <p:cNvPr id="62" name="Shape 60"/>
           <p:cNvSpPr/>
           <p:nvPr/>
         </p:nvSpPr>
@@ -3660,7 +3902,7 @@
       </p:sp>
       <p:sp>
         <p:nvSpPr>
-          <p:cNvPr id="55" name="Text 53"/>
+          <p:cNvPr id="63" name="Text 61"/>
           <p:cNvSpPr txBox="1"/>
           <p:nvPr/>
         </p:nvSpPr>
@@ -3699,7 +3941,7 @@
       </p:sp>
       <p:sp>
         <p:nvSpPr>
-          <p:cNvPr id="56" name="Shape 54"/>
+          <p:cNvPr id="64" name="Shape 62"/>
           <p:cNvSpPr/>
           <p:nvPr/>
         </p:nvSpPr>
@@ -3726,7 +3968,7 @@
       </p:sp>
       <p:sp>
         <p:nvSpPr>
-          <p:cNvPr id="57" name="Text 55"/>
+          <p:cNvPr id="65" name="Text 63"/>
           <p:cNvSpPr txBox="1"/>
           <p:nvPr/>
         </p:nvSpPr>
@@ -3765,7 +4007,7 @@
       </p:sp>
       <p:sp>
         <p:nvSpPr>
-          <p:cNvPr id="58" name="Text 56"/>
+          <p:cNvPr id="66" name="Text 64"/>
           <p:cNvSpPr txBox="1"/>
           <p:nvPr/>
         </p:nvSpPr>
@@ -3804,7 +4046,7 @@
       </p:sp>
       <p:sp>
         <p:nvSpPr>
-          <p:cNvPr id="59" name="Shape 57"/>
+          <p:cNvPr id="67" name="Shape 65"/>
           <p:cNvSpPr/>
           <p:nvPr/>
         </p:nvSpPr>
@@ -3831,7 +4073,7 @@
       </p:sp>
       <p:sp>
         <p:nvSpPr>
-          <p:cNvPr id="60" name="Text 58"/>
+          <p:cNvPr id="68" name="Text 66"/>
           <p:cNvSpPr txBox="1"/>
           <p:nvPr/>
         </p:nvSpPr>
@@ -3870,7 +4112,7 @@
       </p:sp>
       <p:sp>
         <p:nvSpPr>
-          <p:cNvPr id="61" name="Text 59"/>
+          <p:cNvPr id="69" name="Text 67"/>
           <p:cNvSpPr txBox="1"/>
           <p:nvPr/>
         </p:nvSpPr>
@@ -3909,7 +4151,7 @@
       </p:sp>
       <p:sp>
         <p:nvSpPr>
-          <p:cNvPr id="62" name="Shape 60"/>
+          <p:cNvPr id="70" name="Shape 68"/>
           <p:cNvSpPr/>
           <p:nvPr/>
         </p:nvSpPr>
@@ -3936,7 +4178,7 @@
       </p:sp>
       <p:sp>
         <p:nvSpPr>
-          <p:cNvPr id="63" name="Text 61"/>
+          <p:cNvPr id="71" name="Text 69"/>
           <p:cNvSpPr txBox="1"/>
           <p:nvPr/>
         </p:nvSpPr>
@@ -3975,7 +4217,7 @@
       </p:sp>
       <p:sp>
         <p:nvSpPr>
-          <p:cNvPr id="64" name="Text 62"/>
+          <p:cNvPr id="72" name="Text 70"/>
           <p:cNvSpPr txBox="1"/>
           <p:nvPr/>
         </p:nvSpPr>
@@ -4014,7 +4256,7 @@
       </p:sp>
       <p:sp>
         <p:nvSpPr>
-          <p:cNvPr id="65" name="Shape 63"/>
+          <p:cNvPr id="73" name="Shape 71"/>
           <p:cNvSpPr/>
           <p:nvPr/>
         </p:nvSpPr>
@@ -4041,7 +4283,7 @@
       </p:sp>
       <p:sp>
         <p:nvSpPr>
-          <p:cNvPr id="66" name="Text 64"/>
+          <p:cNvPr id="74" name="Text 72"/>
           <p:cNvSpPr txBox="1"/>
           <p:nvPr/>
         </p:nvSpPr>
@@ -4080,7 +4322,7 @@
       </p:sp>
       <p:sp>
         <p:nvSpPr>
-          <p:cNvPr id="67" name="Text 65"/>
+          <p:cNvPr id="75" name="Text 73"/>
           <p:cNvSpPr txBox="1"/>
           <p:nvPr/>
         </p:nvSpPr>
@@ -4119,7 +4361,7 @@
       </p:sp>
       <p:sp>
         <p:nvSpPr>
-          <p:cNvPr id="68" name="Shape 66"/>
+          <p:cNvPr id="76" name="Shape 74"/>
           <p:cNvSpPr/>
           <p:nvPr/>
         </p:nvSpPr>
@@ -4146,7 +4388,7 @@
       </p:sp>
       <p:sp>
         <p:nvSpPr>
-          <p:cNvPr id="69" name="Text 67"/>
+          <p:cNvPr id="77" name="Text 75"/>
           <p:cNvSpPr txBox="1"/>
           <p:nvPr/>
         </p:nvSpPr>
@@ -4185,7 +4427,7 @@
       </p:sp>
       <p:sp>
         <p:nvSpPr>
-          <p:cNvPr id="70" name="Text 68"/>
+          <p:cNvPr id="78" name="Text 76"/>
           <p:cNvSpPr txBox="1"/>
           <p:nvPr/>
         </p:nvSpPr>
@@ -4224,7 +4466,7 @@
       </p:sp>
       <p:sp>
         <p:nvSpPr>
-          <p:cNvPr id="71" name="Shape 69"/>
+          <p:cNvPr id="79" name="Shape 77"/>
           <p:cNvSpPr/>
           <p:nvPr/>
         </p:nvSpPr>
@@ -4251,7 +4493,7 @@
       </p:sp>
       <p:sp>
         <p:nvSpPr>
-          <p:cNvPr id="72" name="Text 70"/>
+          <p:cNvPr id="80" name="Text 78"/>
           <p:cNvSpPr txBox="1"/>
           <p:nvPr/>
         </p:nvSpPr>
@@ -4290,7 +4532,7 @@
       </p:sp>
       <p:sp>
         <p:nvSpPr>
-          <p:cNvPr id="73" name="Text 71"/>
+          <p:cNvPr id="81" name="Text 79"/>
           <p:cNvSpPr txBox="1"/>
           <p:nvPr/>
         </p:nvSpPr>
@@ -4329,7 +4571,7 @@
       </p:sp>
       <p:sp>
         <p:nvSpPr>
-          <p:cNvPr id="74" name="Shape 72"/>
+          <p:cNvPr id="82" name="Shape 80"/>
           <p:cNvSpPr/>
           <p:nvPr/>
         </p:nvSpPr>
@@ -4356,7 +4598,7 @@
       </p:sp>
       <p:sp>
         <p:nvSpPr>
-          <p:cNvPr id="75" name="Text 73"/>
+          <p:cNvPr id="83" name="Text 81"/>
           <p:cNvSpPr txBox="1"/>
           <p:nvPr/>
         </p:nvSpPr>
@@ -4395,7 +4637,7 @@
       </p:sp>
       <p:sp>
         <p:nvSpPr>
-          <p:cNvPr id="76" name="Shape 74"/>
+          <p:cNvPr id="84" name="Shape 82"/>
           <p:cNvSpPr/>
           <p:nvPr/>
         </p:nvSpPr>
@@ -4420,7 +4662,7 @@
       </p:sp>
       <p:sp>
         <p:nvSpPr>
-          <p:cNvPr id="77" name="Shape 75"/>
+          <p:cNvPr id="85" name="Shape 83"/>
           <p:cNvSpPr/>
           <p:nvPr/>
         </p:nvSpPr>
@@ -4445,7 +4687,7 @@
       </p:sp>
       <p:sp>
         <p:nvSpPr>
-          <p:cNvPr id="78" name="Text 76"/>
+          <p:cNvPr id="86" name="Text 84"/>
           <p:cNvSpPr txBox="1"/>
           <p:nvPr/>
         </p:nvSpPr>
@@ -4484,7 +4726,7 @@
       </p:sp>
       <p:sp>
         <p:nvSpPr>
-          <p:cNvPr id="79" name="Shape 77"/>
+          <p:cNvPr id="87" name="Shape 85"/>
           <p:cNvSpPr/>
           <p:nvPr/>
         </p:nvSpPr>
@@ -4511,7 +4753,7 @@
       </p:sp>
       <p:sp>
         <p:nvSpPr>
-          <p:cNvPr id="80" name="Text 78"/>
+          <p:cNvPr id="88" name="Text 86"/>
           <p:cNvSpPr txBox="1"/>
           <p:nvPr/>
         </p:nvSpPr>
@@ -4550,7 +4792,7 @@
       </p:sp>
       <p:sp>
         <p:nvSpPr>
-          <p:cNvPr id="81" name="Text 79"/>
+          <p:cNvPr id="89" name="Text 87"/>
           <p:cNvSpPr txBox="1"/>
           <p:nvPr/>
         </p:nvSpPr>
@@ -4589,7 +4831,7 @@
       </p:sp>
       <p:sp>
         <p:nvSpPr>
-          <p:cNvPr id="82" name="Shape 80"/>
+          <p:cNvPr id="90" name="Shape 88"/>
           <p:cNvSpPr/>
           <p:nvPr/>
         </p:nvSpPr>
@@ -4616,7 +4858,7 @@
       </p:sp>
       <p:sp>
         <p:nvSpPr>
-          <p:cNvPr id="83" name="Text 81"/>
+          <p:cNvPr id="91" name="Text 89"/>
           <p:cNvSpPr txBox="1"/>
           <p:nvPr/>
         </p:nvSpPr>
@@ -4655,7 +4897,7 @@
       </p:sp>
       <p:sp>
         <p:nvSpPr>
-          <p:cNvPr id="84" name="Text 82"/>
+          <p:cNvPr id="92" name="Text 90"/>
           <p:cNvSpPr txBox="1"/>
           <p:nvPr/>
         </p:nvSpPr>
@@ -4694,7 +4936,7 @@
       </p:sp>
       <p:sp>
         <p:nvSpPr>
-          <p:cNvPr id="85" name="Shape 83"/>
+          <p:cNvPr id="93" name="Shape 91"/>
           <p:cNvSpPr/>
           <p:nvPr/>
         </p:nvSpPr>
@@ -4719,7 +4961,7 @@
       </p:sp>
       <p:sp>
         <p:nvSpPr>
-          <p:cNvPr id="86" name="Text 84"/>
+          <p:cNvPr id="94" name="Text 92"/>
           <p:cNvSpPr txBox="1"/>
           <p:nvPr/>
         </p:nvSpPr>
@@ -4758,7 +5000,7 @@
       </p:sp>
       <p:sp>
         <p:nvSpPr>
-          <p:cNvPr id="87" name="Shape 85"/>
+          <p:cNvPr id="95" name="Shape 93"/>
           <p:cNvSpPr/>
           <p:nvPr/>
         </p:nvSpPr>
@@ -4785,7 +5027,7 @@
       </p:sp>
       <p:sp>
         <p:nvSpPr>
-          <p:cNvPr id="88" name="Text 86"/>
+          <p:cNvPr id="96" name="Text 94"/>
           <p:cNvSpPr txBox="1"/>
           <p:nvPr/>
         </p:nvSpPr>
@@ -4824,7 +5066,7 @@
       </p:sp>
       <p:sp>
         <p:nvSpPr>
-          <p:cNvPr id="89" name="Text 87"/>
+          <p:cNvPr id="97" name="Text 95"/>
           <p:cNvSpPr txBox="1"/>
           <p:nvPr/>
         </p:nvSpPr>
@@ -4863,7 +5105,7 @@
       </p:sp>
       <p:sp>
         <p:nvSpPr>
-          <p:cNvPr id="90" name="Shape 88"/>
+          <p:cNvPr id="98" name="Shape 96"/>
           <p:cNvSpPr/>
           <p:nvPr/>
         </p:nvSpPr>
@@ -4890,7 +5132,7 @@
       </p:sp>
       <p:sp>
         <p:nvSpPr>
-          <p:cNvPr id="91" name="Text 89"/>
+          <p:cNvPr id="99" name="Text 97"/>
           <p:cNvSpPr txBox="1"/>
           <p:nvPr/>
         </p:nvSpPr>
@@ -4929,7 +5171,7 @@
       </p:sp>
       <p:sp>
         <p:nvSpPr>
-          <p:cNvPr id="92" name="Text 90"/>
+          <p:cNvPr id="100" name="Text 98"/>
           <p:cNvSpPr txBox="1"/>
           <p:nvPr/>
         </p:nvSpPr>
@@ -4960,7 +5202,7 @@
                 <a:ea typeface="Calibri" pitchFamily="34" charset="-122"/>
                 <a:cs typeface="Calibri" pitchFamily="34" charset="-120"/>
               </a:rPr>
-              <a:t>API trigger: emails approver</a:t>
+              <a:t>API trigger: emails the links</a:t>
             </a:r>
             <a:endParaRPr lang="en-US" sz="800" dirty="0"/>
           </a:p>
@@ -4968,7 +5210,7 @@
       </p:sp>
       <p:sp>
         <p:nvSpPr>
-          <p:cNvPr id="93" name="Shape 91"/>
+          <p:cNvPr id="101" name="Shape 99"/>
           <p:cNvSpPr/>
           <p:nvPr/>
         </p:nvSpPr>
@@ -4993,7 +5235,7 @@
       </p:sp>
       <p:sp>
         <p:nvSpPr>
-          <p:cNvPr id="94" name="Text 92"/>
+          <p:cNvPr id="102" name="Text 100"/>
           <p:cNvSpPr txBox="1"/>
           <p:nvPr/>
         </p:nvSpPr>
@@ -5032,7 +5274,7 @@
       </p:sp>
       <p:sp>
         <p:nvSpPr>
-          <p:cNvPr id="95" name="Shape 93"/>
+          <p:cNvPr id="103" name="Shape 101"/>
           <p:cNvSpPr/>
           <p:nvPr/>
         </p:nvSpPr>
@@ -5059,7 +5301,7 @@
       </p:sp>
       <p:sp>
         <p:nvSpPr>
-          <p:cNvPr id="96" name="Text 94"/>
+          <p:cNvPr id="104" name="Text 102"/>
           <p:cNvSpPr txBox="1"/>
           <p:nvPr/>
         </p:nvSpPr>
@@ -5098,7 +5340,7 @@
       </p:sp>
       <p:sp>
         <p:nvSpPr>
-          <p:cNvPr id="97" name="Text 95"/>
+          <p:cNvPr id="105" name="Text 103"/>
           <p:cNvSpPr txBox="1"/>
           <p:nvPr/>
         </p:nvSpPr>
@@ -5137,7 +5379,7 @@
       </p:sp>
       <p:sp>
         <p:nvSpPr>
-          <p:cNvPr id="98" name="Shape 96"/>
+          <p:cNvPr id="106" name="Shape 104"/>
           <p:cNvSpPr/>
           <p:nvPr/>
         </p:nvSpPr>
@@ -5162,7 +5404,7 @@
       </p:sp>
       <p:sp>
         <p:nvSpPr>
-          <p:cNvPr id="99" name="Shape 97"/>
+          <p:cNvPr id="107" name="Shape 105"/>
           <p:cNvSpPr/>
           <p:nvPr/>
         </p:nvSpPr>
@@ -5187,7 +5429,7 @@
       </p:sp>
       <p:sp>
         <p:nvSpPr>
-          <p:cNvPr id="100" name="Shape 98"/>
+          <p:cNvPr id="108" name="Shape 106"/>
           <p:cNvSpPr/>
           <p:nvPr/>
         </p:nvSpPr>
@@ -5212,7 +5454,7 @@
       </p:sp>
       <p:sp>
         <p:nvSpPr>
-          <p:cNvPr id="101" name="Text 99"/>
+          <p:cNvPr id="109" name="Text 107"/>
           <p:cNvSpPr txBox="1"/>
           <p:nvPr/>
         </p:nvSpPr>

</xml_diff>

<commit_message>
Docs and deck: native Application Integration approval is the default; Cloud Run links parked
Co-Authored-By: Claude Sonnet 5.5 <noreply@anthropic.com>
Claude-Session: https://claude.ai/code/session_01Aj5vE1JNcAxiTqppU4PS2Y
</commit_message>
<xml_diff>
--- a/docs/Campaign_Provisioner_Management_Deck.pptx
+++ b/docs/Campaign_Provisioner_Management_Deck.pptx
@@ -680,7 +680,7 @@
           <a:p>
             <a:r>
               <a:rPr lang="en-US" dirty="0"/>
-              <a:t>Reference architecture. Every element is a native, editable PowerPoint shape or text box - no images. Google BigQuery holds all data (inventory, vendor prices, budget ledger, approval policy, approver emails, audit log). Google Application Integration runs the two workflow actions: create_purchase_order and notify_approver (sends the approval email). The agent is deployed to Vertex AI Agent Engine (hosted runtime and managed sessions). The human approval is an emailed Approve / Reject link handled by a small Cloud Run service (signed link, no login), which then triggers the order; purchase orders are blocked in code without an approved budget.</a:t>
+              <a:t>Reference architecture. Every element is a native, editable PowerPoint shape or text box - no images. Google BigQuery holds all data (inventory, vendor prices, budget ledger, approval policy, approver emails, audit log). Google Application Integration runs the workflow actions: create_purchase_order and request_approval (a native Approval task that emails the approver Approve / Reject and waits; a notify_approver email trigger also exists). The agent is deployed to Vertex AI Agent Engine (hosted runtime and managed sessions). The human approval is an emailed Approve / Reject link handled by a small Cloud Run service (signed link, no login), which then triggers the order; purchase orders are blocked in code without an approved budget.</a:t>
             </a:r>
             <a:endParaRPr lang="en-US" dirty="0"/>
           </a:p>
@@ -1578,7 +1578,7 @@
                 <a:ea typeface="Calibri" pitchFamily="34" charset="-122"/>
                 <a:cs typeface="Calibri" pitchFamily="34" charset="-120"/>
               </a:rPr>
-              <a:t>Approval tiers and approver emails are stored in BigQuery. Routine spend is approved by policy. Higher tiers email the approver an Approve / Reject link (no login needed); the click triggers the order (Marketing Director, or VP Marketing and Finance Controller).</a:t>
+              <a:t>Approval tiers and approver emails are stored in BigQuery. Routine spend is approved by policy. Higher tiers start an Application Integration approval: the approver gets an Approve / Reject email, and the decision creates the order or releases the stock (Marketing Director, or VP Marketing and Finance Controller).</a:t>
             </a:r>
             <a:endParaRPr lang="en-US" sz="1200" dirty="0"/>
           </a:p>
@@ -2359,7 +2359,7 @@
                 <a:ea typeface="Calibri" pitchFamily="34" charset="-122"/>
                 <a:cs typeface="Calibri" pitchFamily="34" charset="-120"/>
               </a:rPr>
-              <a:t>Email: Approve / Reject link</a:t>
+              <a:t>Email: Approve / Reject</a:t>
             </a:r>
             <a:endParaRPr lang="en-US" sz="800" dirty="0"/>
           </a:p>
@@ -2425,7 +2425,7 @@
                 <a:ea typeface="Calibri" pitchFamily="34" charset="-122"/>
                 <a:cs typeface="Calibri" pitchFamily="34" charset="-120"/>
               </a:rPr>
-              <a:t>Approval Link Service</a:t>
+              <a:t>Approval task</a:t>
             </a:r>
             <a:endParaRPr lang="en-US" sz="800" dirty="0"/>
           </a:p>
@@ -2464,7 +2464,7 @@
                 <a:ea typeface="Calibri" pitchFamily="34" charset="-122"/>
                 <a:cs typeface="Calibri" pitchFamily="34" charset="-120"/>
               </a:rPr>
-              <a:t>Cloud Run, no login</a:t>
+              <a:t>Application Integration</a:t>
             </a:r>
             <a:endParaRPr lang="en-US" sz="800" dirty="0"/>
           </a:p>
@@ -2762,7 +2762,7 @@
                 <a:ea typeface="Calibri" pitchFamily="34" charset="-122"/>
                 <a:cs typeface="Calibri" pitchFamily="34" charset="-120"/>
               </a:rPr>
-              <a:t>Greeting &amp; Intent  •  Multi-Agent Coordination  •  State Coordination  •  Human Approval Gate (email link)  •  Result Aggregation</a:t>
+              <a:t>Greeting &amp; Intent  •  Multi-Agent Coordination  •  State Coordination  •  Human Approval Gate (Application Integration)  •  Result Aggregation</a:t>
             </a:r>
             <a:endParaRPr lang="en-US" sz="850" dirty="0"/>
           </a:p>
@@ -3364,7 +3364,7 @@
                 <a:ea typeface="Calibri" pitchFamily="34" charset="-122"/>
                 <a:cs typeface="Calibri" pitchFamily="34" charset="-120"/>
               </a:rPr>
-              <a:t>(Validate &amp; Notify)</a:t>
+              <a:t>(Validate)</a:t>
             </a:r>
             <a:endParaRPr lang="en-US" sz="800" dirty="0"/>
           </a:p>
@@ -3465,7 +3465,7 @@
                 <a:ea typeface="Calibri" pitchFamily="34" charset="-122"/>
                 <a:cs typeface="Calibri" pitchFamily="34" charset="-120"/>
               </a:rPr>
-              <a:t>Approver emailed a link by the Orchestrator</a:t>
+              <a:t>Orchestrator starts the approval</a:t>
             </a:r>
             <a:endParaRPr lang="en-US" sz="850" dirty="0"/>
           </a:p>
@@ -5163,7 +5163,7 @@
                 <a:ea typeface="Calibri" pitchFamily="34" charset="-122"/>
                 <a:cs typeface="Calibri" pitchFamily="34" charset="-120"/>
               </a:rPr>
-              <a:t>notify_approver</a:t>
+              <a:t>request_approval</a:t>
             </a:r>
             <a:endParaRPr lang="en-US" sz="800" dirty="0"/>
           </a:p>
@@ -5202,7 +5202,7 @@
                 <a:ea typeface="Calibri" pitchFamily="34" charset="-122"/>
                 <a:cs typeface="Calibri" pitchFamily="34" charset="-120"/>
               </a:rPr>
-              <a:t>API trigger: emails the links</a:t>
+              <a:t>Approval task: Approve / Reject email</a:t>
             </a:r>
             <a:endParaRPr lang="en-US" sz="800" dirty="0"/>
           </a:p>

</xml_diff>

<commit_message>
Docs and deck: batch tools, SUBAGENT_MODE / Gemini Enterprise, approval flow status, updated demo numbers and verification status
Co-Authored-By: Claude Sonnet 5.5 <noreply@anthropic.com>
Claude-Session: https://claude.ai/code/session_01Aj5vE1JNcAxiTqppU4PS2Y
</commit_message>
<xml_diff>
--- a/docs/Campaign_Provisioner_Management_Deck.pptx
+++ b/docs/Campaign_Provisioner_Management_Deck.pptx
@@ -680,7 +680,7 @@
           <a:p>
             <a:r>
               <a:rPr lang="en-US" dirty="0"/>
-              <a:t>Reference architecture. Every element is a native, editable PowerPoint shape or text box - no images. Google BigQuery holds all data (inventory, vendor prices, budget ledger, approval policy, approver emails, audit log). Google Application Integration runs the workflow actions: create_purchase_order and request_approval (a native Approval task that emails the approver Approve / Reject and waits; a notify_approver email trigger also exists). The agent is deployed to Vertex AI Agent Engine (hosted runtime and managed sessions). The human approval is an emailed Approve / Reject link handled by a small Cloud Run service (signed link, no login), which then triggers the order; purchase orders are blocked in code without an approved budget.</a:t>
+              <a:t>Reference architecture. Every element is a native, editable PowerPoint shape or text box - no images. Google BigQuery holds all data (inventory, vendor prices, budget ledger, approval policy, approver emails, audit log). Google Application Integration runs the workflow actions: create_purchase_order and request_approval (a native Approval task that emails the approver Approve / Reject and waits; a notify_approver email trigger also exists). The agent runs on Vertex AI Agent Engine and is used from the Gemini Enterprise chat; for that front end the root agent calls the three specialists as tools so it writes every reply, and each specialist uses batch tools to keep a request to about a minute.. The agent is deployed to Vertex AI Agent Engine (hosted runtime and managed sessions). The human approval is an emailed Approve / Reject link handled by a small Cloud Run service (signed link, no login), which then triggers the order; purchase orders are blocked in code without an approved budget.</a:t>
             </a:r>
             <a:endParaRPr lang="en-US" dirty="0"/>
           </a:p>
@@ -3021,7 +3021,7 @@
                 <a:ea typeface="Calibri" pitchFamily="34" charset="-122"/>
                 <a:cs typeface="Calibri" pitchFamily="34" charset="-120"/>
               </a:rPr>
-              <a:t>Read stock (BigQuery)</a:t>
+              <a:t>Match items to SKUs (BigQuery)</a:t>
             </a:r>
             <a:endParaRPr lang="en-US" sz="850" dirty="0"/>
           </a:p>
@@ -3039,7 +3039,7 @@
                 <a:ea typeface="Calibri" pitchFamily="34" charset="-122"/>
                 <a:cs typeface="Calibri" pitchFamily="34" charset="-120"/>
               </a:rPr>
-              <a:t>Reserve units (BigQuery)</a:t>
+              <a:t>Reserve stock, all items at once</a:t>
             </a:r>
             <a:endParaRPr lang="en-US" sz="850" dirty="0"/>
           </a:p>
@@ -3225,7 +3225,7 @@
                 <a:ea typeface="Calibri" pitchFamily="34" charset="-122"/>
                 <a:cs typeface="Calibri" pitchFamily="34" charset="-120"/>
               </a:rPr>
-              <a:t>Fetch quotes (BigQuery)</a:t>
+              <a:t>Quote all shortfalls at once</a:t>
             </a:r>
             <a:endParaRPr lang="en-US" sz="850" dirty="0"/>
           </a:p>
@@ -3243,7 +3243,7 @@
                 <a:ea typeface="Calibri" pitchFamily="34" charset="-122"/>
                 <a:cs typeface="Calibri" pitchFamily="34" charset="-120"/>
               </a:rPr>
-              <a:t>Rank on price &amp; lead time</a:t>
+              <a:t>Cheapest vendor, lead time</a:t>
             </a:r>
             <a:endParaRPr lang="en-US" sz="850" dirty="0"/>
           </a:p>
@@ -3429,7 +3429,7 @@
                 <a:ea typeface="Calibri" pitchFamily="34" charset="-122"/>
                 <a:cs typeface="Calibri" pitchFamily="34" charset="-120"/>
               </a:rPr>
-              <a:t>Check budget &amp; tier (BigQuery)</a:t>
+              <a:t>Budget + tier in one call (BigQuery)</a:t>
             </a:r>
             <a:endParaRPr lang="en-US" sz="850" dirty="0"/>
           </a:p>

</xml_diff>

<commit_message>
Specialists are always called as tools by the root (all platforms); remove SUBAGENT_MODE and hand-over wiring; docs and deck updated
Co-Authored-By: Claude Sonnet 5.5 <noreply@anthropic.com>
Claude-Session: https://claude.ai/code/session_01Aj5vE1JNcAxiTqppU4PS2Y
</commit_message>
<xml_diff>
--- a/docs/Campaign_Provisioner_Management_Deck.pptx
+++ b/docs/Campaign_Provisioner_Management_Deck.pptx
@@ -680,7 +680,7 @@
           <a:p>
             <a:r>
               <a:rPr lang="en-US" dirty="0"/>
-              <a:t>Reference architecture. Every element is a native, editable PowerPoint shape or text box - no images. Google BigQuery holds all data (inventory, vendor prices, budget ledger, approval policy, approver emails, audit log). Google Application Integration runs the workflow actions: create_purchase_order and request_approval (a native Approval task that emails the approver Approve / Reject and waits; a notify_approver email trigger also exists). The agent runs on Vertex AI Agent Engine and is used from the Gemini Enterprise chat; for that front end the root agent calls the three specialists as tools so it writes every reply, and each specialist uses batch tools to keep a request to about a minute.. The agent is deployed to Vertex AI Agent Engine (hosted runtime and managed sessions). The human approval is an emailed Approve / Reject link handled by a small Cloud Run service (signed link, no login), which then triggers the order; purchase orders are blocked in code without an approved budget.</a:t>
+              <a:t>Reference architecture. Every element is a native, editable PowerPoint shape or text box - no images. Google BigQuery holds all data (inventory, vendor prices, budget ledger, approval policy, approver emails, audit log). Google Application Integration runs the workflow actions: create_purchase_order and request_approval (a native Approval task that emails the approver Approve / Reject and waits; a notify_approver email trigger also exists). The agent runs on Vertex AI Agent Engine and is used from the Gemini Enterprise chat; the root agent calls the three specialist agents as tools (ADK AgentTool), so the root writes every reply on every platform, and each specialist uses batch tools to keep a request to about a minute.. The agent is deployed to Vertex AI Agent Engine (hosted runtime and managed sessions). The human approval is an emailed Approve / Reject link handled by a small Cloud Run service (signed link, no login), which then triggers the order; purchase orders are blocked in code without an approved budget.</a:t>
             </a:r>
             <a:endParaRPr lang="en-US" dirty="0"/>
           </a:p>
@@ -2802,7 +2802,7 @@
         <p:spPr>
           <a:xfrm>
             <a:off x="2880360" y="2496312"/>
-            <a:ext cx="914400" cy="201168"/>
+            <a:ext cx="2743200" cy="201168"/>
           </a:xfrm>
           <a:prstGeom prst="roundRect">
             <a:avLst>
@@ -2829,7 +2829,7 @@
         <p:spPr>
           <a:xfrm>
             <a:off x="2880360" y="2496312"/>
-            <a:ext cx="914400" cy="201168"/>
+            <a:ext cx="2743200" cy="201168"/>
           </a:xfrm>
           <a:prstGeom prst="rect">
             <a:avLst/>
@@ -2853,7 +2853,7 @@
                 <a:ea typeface="Calibri" pitchFamily="34" charset="-122"/>
                 <a:cs typeface="Calibri" pitchFamily="34" charset="-120"/>
               </a:rPr>
-              <a:t>3 Sub Agents</a:t>
+              <a:t>3 Sub Agents (called by the root as tools)</a:t>
             </a:r>
             <a:endParaRPr lang="en-US" sz="800" dirty="0"/>
           </a:p>

</xml_diff>